<commit_message>
Removed letter as not needed
</commit_message>
<xml_diff>
--- a/chapter_06/figures/break_down_scores.pptx
+++ b/chapter_06/figures/break_down_scores.pptx
@@ -2,12 +2,12 @@
 <file path=ppt/presentation.xml><?xml version="1.0" encoding="utf-8"?>
 <p:presentation xmlns:a="http://schemas.openxmlformats.org/drawingml/2006/main" xmlns:r="http://schemas.openxmlformats.org/officeDocument/2006/relationships" xmlns:p="http://schemas.openxmlformats.org/presentationml/2006/main" saveSubsetFonts="1">
   <p:sldMasterIdLst>
-    <p:sldMasterId id="2147483756" r:id="rId1"/>
+    <p:sldMasterId id="2147483768" r:id="rId1"/>
   </p:sldMasterIdLst>
   <p:sldIdLst>
     <p:sldId id="256" r:id="rId2"/>
   </p:sldIdLst>
-  <p:sldSz cx="4140200" cy="1476375"/>
+  <p:sldSz cx="4140200" cy="1295400"/>
   <p:notesSz cx="6858000" cy="9144000"/>
   <p:defaultTextStyle>
     <a:defPPr>
@@ -115,7 +115,7 @@
 <file path=ppt/revisionInfo.xml><?xml version="1.0" encoding="utf-8"?>
 <p1510:revInfo xmlns:a="http://schemas.openxmlformats.org/drawingml/2006/main" xmlns:r="http://schemas.openxmlformats.org/officeDocument/2006/relationships" xmlns:p1510="http://schemas.microsoft.com/office/powerpoint/2015/10/main">
   <p1510:revLst>
-    <p1510:client id="{BB96EA5D-C3BE-427B-8FE9-FA1A6A06E6F8}" v="2" dt="2026-01-26T22:56:17.905"/>
+    <p1510:client id="{BB96EA5D-C3BE-427B-8FE9-FA1A6A06E6F8}" v="4" dt="2026-01-26T22:58:50.421"/>
   </p1510:revLst>
 </p1510:revInfo>
 </file>
@@ -125,12 +125,12 @@
   <pc:docChgLst>
     <pc:chgData name="Fatima Pillosu" userId="a6295d4dc9e22643" providerId="LiveId" clId="{87453732-75AC-4426-B5D3-B7C69C2D4F54}"/>
     <pc:docChg chg="undo custSel modSld">
-      <pc:chgData name="Fatima Pillosu" userId="a6295d4dc9e22643" providerId="LiveId" clId="{87453732-75AC-4426-B5D3-B7C69C2D4F54}" dt="2026-01-26T22:56:22.404" v="244" actId="1035"/>
+      <pc:chgData name="Fatima Pillosu" userId="a6295d4dc9e22643" providerId="LiveId" clId="{87453732-75AC-4426-B5D3-B7C69C2D4F54}" dt="2026-01-26T22:58:50.421" v="277"/>
       <pc:docMkLst>
         <pc:docMk/>
       </pc:docMkLst>
       <pc:sldChg chg="addSp delSp modSp mod">
-        <pc:chgData name="Fatima Pillosu" userId="a6295d4dc9e22643" providerId="LiveId" clId="{87453732-75AC-4426-B5D3-B7C69C2D4F54}" dt="2026-01-26T22:56:22.404" v="244" actId="1035"/>
+        <pc:chgData name="Fatima Pillosu" userId="a6295d4dc9e22643" providerId="LiveId" clId="{87453732-75AC-4426-B5D3-B7C69C2D4F54}" dt="2026-01-26T22:58:50.421" v="277"/>
         <pc:sldMkLst>
           <pc:docMk/>
           <pc:sldMk cId="1573992039" sldId="256"/>
@@ -143,12 +143,44 @@
             <ac:spMk id="2" creationId="{4C835313-E0D5-C4EE-7654-ED9A8FE275BF}"/>
           </ac:spMkLst>
         </pc:spChg>
+        <pc:spChg chg="add del">
+          <ac:chgData name="Fatima Pillosu" userId="a6295d4dc9e22643" providerId="LiveId" clId="{87453732-75AC-4426-B5D3-B7C69C2D4F54}" dt="2026-01-26T22:58:38.751" v="275" actId="478"/>
+          <ac:spMkLst>
+            <pc:docMk/>
+            <pc:sldMk cId="1573992039" sldId="256"/>
+            <ac:spMk id="2" creationId="{F475F43C-18C5-4B12-E619-512343645CF0}"/>
+          </ac:spMkLst>
+        </pc:spChg>
+        <pc:spChg chg="del">
+          <ac:chgData name="Fatima Pillosu" userId="a6295d4dc9e22643" providerId="LiveId" clId="{87453732-75AC-4426-B5D3-B7C69C2D4F54}" dt="2026-01-26T22:58:40.537" v="276" actId="21"/>
+          <ac:spMkLst>
+            <pc:docMk/>
+            <pc:sldMk cId="1573992039" sldId="256"/>
+            <ac:spMk id="3" creationId="{F4E1EB47-FB49-B221-8F40-6FAAC8188E34}"/>
+          </ac:spMkLst>
+        </pc:spChg>
         <pc:spChg chg="add mod">
           <ac:chgData name="Fatima Pillosu" userId="a6295d4dc9e22643" providerId="LiveId" clId="{87453732-75AC-4426-B5D3-B7C69C2D4F54}" dt="2026-01-26T22:56:22.404" v="244" actId="1035"/>
           <ac:spMkLst>
             <pc:docMk/>
             <pc:sldMk cId="1573992039" sldId="256"/>
             <ac:spMk id="5" creationId="{8DD953F0-D574-7288-6232-DB349985D1C7}"/>
+          </ac:spMkLst>
+        </pc:spChg>
+        <pc:spChg chg="mod">
+          <ac:chgData name="Fatima Pillosu" userId="a6295d4dc9e22643" providerId="LiveId" clId="{87453732-75AC-4426-B5D3-B7C69C2D4F54}" dt="2026-01-26T22:58:13.640" v="272" actId="1035"/>
+          <ac:spMkLst>
+            <pc:docMk/>
+            <pc:sldMk cId="1573992039" sldId="256"/>
+            <ac:spMk id="13" creationId="{5CA2A36E-AB3C-E4C2-E36B-5896CE1876A3}"/>
+          </ac:spMkLst>
+        </pc:spChg>
+        <pc:spChg chg="del mod">
+          <ac:chgData name="Fatima Pillosu" userId="a6295d4dc9e22643" providerId="LiveId" clId="{87453732-75AC-4426-B5D3-B7C69C2D4F54}" dt="2026-01-26T22:58:40.537" v="276" actId="21"/>
+          <ac:spMkLst>
+            <pc:docMk/>
+            <pc:sldMk cId="1573992039" sldId="256"/>
+            <ac:spMk id="14" creationId="{4BE5230C-F284-DA67-6488-204B230E83EC}"/>
           </ac:spMkLst>
         </pc:spChg>
         <pc:spChg chg="add mod">
@@ -159,12 +191,28 @@
             <ac:spMk id="19" creationId="{0B7447C1-71A7-53DA-FA4A-60695C6142B4}"/>
           </ac:spMkLst>
         </pc:spChg>
-        <pc:spChg chg="add mod">
-          <ac:chgData name="Fatima Pillosu" userId="a6295d4dc9e22643" providerId="LiveId" clId="{87453732-75AC-4426-B5D3-B7C69C2D4F54}" dt="2026-01-26T22:56:22.404" v="244" actId="1035"/>
+        <pc:spChg chg="add del mod">
+          <ac:chgData name="Fatima Pillosu" userId="a6295d4dc9e22643" providerId="LiveId" clId="{87453732-75AC-4426-B5D3-B7C69C2D4F54}" dt="2026-01-26T22:58:40.537" v="276" actId="21"/>
           <ac:spMkLst>
             <pc:docMk/>
             <pc:sldMk cId="1573992039" sldId="256"/>
             <ac:spMk id="21" creationId="{4B572820-B33D-97E7-3F9A-1E53270FD862}"/>
+          </ac:spMkLst>
+        </pc:spChg>
+        <pc:spChg chg="del mod">
+          <ac:chgData name="Fatima Pillosu" userId="a6295d4dc9e22643" providerId="LiveId" clId="{87453732-75AC-4426-B5D3-B7C69C2D4F54}" dt="2026-01-26T22:58:40.537" v="276" actId="21"/>
+          <ac:spMkLst>
+            <pc:docMk/>
+            <pc:sldMk cId="1573992039" sldId="256"/>
+            <ac:spMk id="22" creationId="{0559E9B8-ED2A-B7C5-CD99-FCCACB55B247}"/>
+          </ac:spMkLst>
+        </pc:spChg>
+        <pc:spChg chg="del mod">
+          <ac:chgData name="Fatima Pillosu" userId="a6295d4dc9e22643" providerId="LiveId" clId="{87453732-75AC-4426-B5D3-B7C69C2D4F54}" dt="2026-01-26T22:58:40.537" v="276" actId="21"/>
+          <ac:spMkLst>
+            <pc:docMk/>
+            <pc:sldMk cId="1573992039" sldId="256"/>
+            <ac:spMk id="24" creationId="{00472CBD-CB17-A7EF-5FDC-A2F6815385EA}"/>
           </ac:spMkLst>
         </pc:spChg>
         <pc:spChg chg="add mod">
@@ -175,16 +223,24 @@
             <ac:spMk id="26" creationId="{6D8A9C3F-217E-9DEA-31D3-F668D73532C6}"/>
           </ac:spMkLst>
         </pc:spChg>
-        <pc:spChg chg="add mod">
-          <ac:chgData name="Fatima Pillosu" userId="a6295d4dc9e22643" providerId="LiveId" clId="{87453732-75AC-4426-B5D3-B7C69C2D4F54}" dt="2026-01-26T22:56:22.404" v="244" actId="1035"/>
+        <pc:spChg chg="add del mod">
+          <ac:chgData name="Fatima Pillosu" userId="a6295d4dc9e22643" providerId="LiveId" clId="{87453732-75AC-4426-B5D3-B7C69C2D4F54}" dt="2026-01-26T22:58:40.537" v="276" actId="21"/>
           <ac:spMkLst>
             <pc:docMk/>
             <pc:sldMk cId="1573992039" sldId="256"/>
             <ac:spMk id="29" creationId="{B9FD6C18-DBDE-1EE4-FADB-2B22F8257AA8}"/>
           </ac:spMkLst>
         </pc:spChg>
-        <pc:spChg chg="add mod">
-          <ac:chgData name="Fatima Pillosu" userId="a6295d4dc9e22643" providerId="LiveId" clId="{87453732-75AC-4426-B5D3-B7C69C2D4F54}" dt="2026-01-26T22:56:22.404" v="244" actId="1035"/>
+        <pc:spChg chg="del mod">
+          <ac:chgData name="Fatima Pillosu" userId="a6295d4dc9e22643" providerId="LiveId" clId="{87453732-75AC-4426-B5D3-B7C69C2D4F54}" dt="2026-01-26T22:58:40.537" v="276" actId="21"/>
+          <ac:spMkLst>
+            <pc:docMk/>
+            <pc:sldMk cId="1573992039" sldId="256"/>
+            <ac:spMk id="31" creationId="{3A123093-7B31-331E-36C8-0D76F6297454}"/>
+          </ac:spMkLst>
+        </pc:spChg>
+        <pc:spChg chg="add del mod">
+          <ac:chgData name="Fatima Pillosu" userId="a6295d4dc9e22643" providerId="LiveId" clId="{87453732-75AC-4426-B5D3-B7C69C2D4F54}" dt="2026-01-26T22:58:40.537" v="276" actId="21"/>
           <ac:spMkLst>
             <pc:docMk/>
             <pc:sldMk cId="1573992039" sldId="256"/>
@@ -199,8 +255,32 @@
             <ac:spMk id="36" creationId="{0DA10788-F022-5F4F-7E6A-BC6318793D52}"/>
           </ac:spMkLst>
         </pc:spChg>
-        <pc:spChg chg="add mod">
-          <ac:chgData name="Fatima Pillosu" userId="a6295d4dc9e22643" providerId="LiveId" clId="{87453732-75AC-4426-B5D3-B7C69C2D4F54}" dt="2026-01-26T22:56:22.404" v="244" actId="1035"/>
+        <pc:spChg chg="del mod">
+          <ac:chgData name="Fatima Pillosu" userId="a6295d4dc9e22643" providerId="LiveId" clId="{87453732-75AC-4426-B5D3-B7C69C2D4F54}" dt="2026-01-26T22:58:40.537" v="276" actId="21"/>
+          <ac:spMkLst>
+            <pc:docMk/>
+            <pc:sldMk cId="1573992039" sldId="256"/>
+            <ac:spMk id="38" creationId="{3F9004C2-032E-AE52-1A5E-5FEED9C5F2DC}"/>
+          </ac:spMkLst>
+        </pc:spChg>
+        <pc:spChg chg="del mod">
+          <ac:chgData name="Fatima Pillosu" userId="a6295d4dc9e22643" providerId="LiveId" clId="{87453732-75AC-4426-B5D3-B7C69C2D4F54}" dt="2026-01-26T22:58:40.537" v="276" actId="21"/>
+          <ac:spMkLst>
+            <pc:docMk/>
+            <pc:sldMk cId="1573992039" sldId="256"/>
+            <ac:spMk id="43" creationId="{6294855B-E047-F82E-4381-14F2D4005F14}"/>
+          </ac:spMkLst>
+        </pc:spChg>
+        <pc:spChg chg="mod">
+          <ac:chgData name="Fatima Pillosu" userId="a6295d4dc9e22643" providerId="LiveId" clId="{87453732-75AC-4426-B5D3-B7C69C2D4F54}" dt="2026-01-26T22:58:24.051" v="273" actId="554"/>
+          <ac:spMkLst>
+            <pc:docMk/>
+            <pc:sldMk cId="1573992039" sldId="256"/>
+            <ac:spMk id="44" creationId="{96350757-4EAD-7E70-7E51-6A44C861C034}"/>
+          </ac:spMkLst>
+        </pc:spChg>
+        <pc:spChg chg="add del mod">
+          <ac:chgData name="Fatima Pillosu" userId="a6295d4dc9e22643" providerId="LiveId" clId="{87453732-75AC-4426-B5D3-B7C69C2D4F54}" dt="2026-01-26T22:58:04.871" v="245" actId="478"/>
           <ac:spMkLst>
             <pc:docMk/>
             <pc:sldMk cId="1573992039" sldId="256"/>
@@ -223,12 +303,84 @@
             <ac:spMk id="55" creationId="{9AFD7136-F527-E69D-7527-B98BDFD517F3}"/>
           </ac:spMkLst>
         </pc:spChg>
-        <pc:spChg chg="mod">
-          <ac:chgData name="Fatima Pillosu" userId="a6295d4dc9e22643" providerId="LiveId" clId="{87453732-75AC-4426-B5D3-B7C69C2D4F54}" dt="2026-01-20T00:06:27.992" v="144"/>
+        <pc:spChg chg="add mod">
+          <ac:chgData name="Fatima Pillosu" userId="a6295d4dc9e22643" providerId="LiveId" clId="{87453732-75AC-4426-B5D3-B7C69C2D4F54}" dt="2026-01-26T22:58:50.421" v="277"/>
           <ac:spMkLst>
             <pc:docMk/>
             <pc:sldMk cId="1573992039" sldId="256"/>
-            <ac:spMk id="832" creationId="{DEE113C7-80D8-F2A4-39D3-70B57205EC60}"/>
+            <ac:spMk id="58" creationId="{255FCF48-52E3-4492-E94D-63EC8B3349BF}"/>
+          </ac:spMkLst>
+        </pc:spChg>
+        <pc:spChg chg="add mod">
+          <ac:chgData name="Fatima Pillosu" userId="a6295d4dc9e22643" providerId="LiveId" clId="{87453732-75AC-4426-B5D3-B7C69C2D4F54}" dt="2026-01-26T22:58:50.421" v="277"/>
+          <ac:spMkLst>
+            <pc:docMk/>
+            <pc:sldMk cId="1573992039" sldId="256"/>
+            <ac:spMk id="70" creationId="{B2A59DDD-285A-7034-B1F5-70C3236EEB8E}"/>
+          </ac:spMkLst>
+        </pc:spChg>
+        <pc:spChg chg="add mod">
+          <ac:chgData name="Fatima Pillosu" userId="a6295d4dc9e22643" providerId="LiveId" clId="{87453732-75AC-4426-B5D3-B7C69C2D4F54}" dt="2026-01-26T22:58:50.421" v="277"/>
+          <ac:spMkLst>
+            <pc:docMk/>
+            <pc:sldMk cId="1573992039" sldId="256"/>
+            <ac:spMk id="72" creationId="{C7497309-3825-8F73-491C-1F065C389560}"/>
+          </ac:spMkLst>
+        </pc:spChg>
+        <pc:spChg chg="add mod">
+          <ac:chgData name="Fatima Pillosu" userId="a6295d4dc9e22643" providerId="LiveId" clId="{87453732-75AC-4426-B5D3-B7C69C2D4F54}" dt="2026-01-26T22:58:50.421" v="277"/>
+          <ac:spMkLst>
+            <pc:docMk/>
+            <pc:sldMk cId="1573992039" sldId="256"/>
+            <ac:spMk id="79" creationId="{06FE1007-0DAE-599E-2214-69669DEB30C2}"/>
+          </ac:spMkLst>
+        </pc:spChg>
+        <pc:spChg chg="add mod">
+          <ac:chgData name="Fatima Pillosu" userId="a6295d4dc9e22643" providerId="LiveId" clId="{87453732-75AC-4426-B5D3-B7C69C2D4F54}" dt="2026-01-26T22:58:50.421" v="277"/>
+          <ac:spMkLst>
+            <pc:docMk/>
+            <pc:sldMk cId="1573992039" sldId="256"/>
+            <ac:spMk id="86" creationId="{AEF79955-9585-5CF1-C444-DDF210469501}"/>
+          </ac:spMkLst>
+        </pc:spChg>
+        <pc:spChg chg="add mod">
+          <ac:chgData name="Fatima Pillosu" userId="a6295d4dc9e22643" providerId="LiveId" clId="{87453732-75AC-4426-B5D3-B7C69C2D4F54}" dt="2026-01-26T22:58:50.421" v="277"/>
+          <ac:spMkLst>
+            <pc:docMk/>
+            <pc:sldMk cId="1573992039" sldId="256"/>
+            <ac:spMk id="89" creationId="{1522668D-8253-2DF2-841F-181CA4892F52}"/>
+          </ac:spMkLst>
+        </pc:spChg>
+        <pc:spChg chg="add mod">
+          <ac:chgData name="Fatima Pillosu" userId="a6295d4dc9e22643" providerId="LiveId" clId="{87453732-75AC-4426-B5D3-B7C69C2D4F54}" dt="2026-01-26T22:58:50.421" v="277"/>
+          <ac:spMkLst>
+            <pc:docMk/>
+            <pc:sldMk cId="1573992039" sldId="256"/>
+            <ac:spMk id="95" creationId="{3E1A0180-88A4-FC9F-9519-D1D7BDCA0811}"/>
+          </ac:spMkLst>
+        </pc:spChg>
+        <pc:spChg chg="add mod">
+          <ac:chgData name="Fatima Pillosu" userId="a6295d4dc9e22643" providerId="LiveId" clId="{87453732-75AC-4426-B5D3-B7C69C2D4F54}" dt="2026-01-26T22:58:50.421" v="277"/>
+          <ac:spMkLst>
+            <pc:docMk/>
+            <pc:sldMk cId="1573992039" sldId="256"/>
+            <ac:spMk id="96" creationId="{59FE1138-74BE-8717-2261-54DC19AC021C}"/>
+          </ac:spMkLst>
+        </pc:spChg>
+        <pc:spChg chg="add mod">
+          <ac:chgData name="Fatima Pillosu" userId="a6295d4dc9e22643" providerId="LiveId" clId="{87453732-75AC-4426-B5D3-B7C69C2D4F54}" dt="2026-01-26T22:58:50.421" v="277"/>
+          <ac:spMkLst>
+            <pc:docMk/>
+            <pc:sldMk cId="1573992039" sldId="256"/>
+            <ac:spMk id="104" creationId="{B7776DAF-AB8C-150D-9732-CC67560B199A}"/>
+          </ac:spMkLst>
+        </pc:spChg>
+        <pc:spChg chg="add mod">
+          <ac:chgData name="Fatima Pillosu" userId="a6295d4dc9e22643" providerId="LiveId" clId="{87453732-75AC-4426-B5D3-B7C69C2D4F54}" dt="2026-01-26T22:58:50.421" v="277"/>
+          <ac:spMkLst>
+            <pc:docMk/>
+            <pc:sldMk cId="1573992039" sldId="256"/>
+            <ac:spMk id="106" creationId="{F6D48A6B-C064-E9C2-ABC9-C06729342EA6}"/>
           </ac:spMkLst>
         </pc:spChg>
         <pc:spChg chg="mod">
@@ -237,14 +389,6 @@
             <pc:docMk/>
             <pc:sldMk cId="1573992039" sldId="256"/>
             <ac:spMk id="833" creationId="{C8C3D13A-BFDD-54C1-8A04-DD3BB24773C4}"/>
-          </ac:spMkLst>
-        </pc:spChg>
-        <pc:spChg chg="add mod">
-          <ac:chgData name="Fatima Pillosu" userId="a6295d4dc9e22643" providerId="LiveId" clId="{87453732-75AC-4426-B5D3-B7C69C2D4F54}" dt="2026-01-20T00:06:27.992" v="144"/>
-          <ac:spMkLst>
-            <pc:docMk/>
-            <pc:sldMk cId="1573992039" sldId="256"/>
-            <ac:spMk id="834" creationId="{255FCF48-52E3-4492-E94D-63EC8B3349BF}"/>
           </ac:spMkLst>
         </pc:spChg>
         <pc:spChg chg="mod">
@@ -261,14 +405,6 @@
             <pc:docMk/>
             <pc:sldMk cId="1573992039" sldId="256"/>
             <ac:spMk id="836" creationId="{0770A906-9CF0-0CA7-E0F3-6CE28EFD5D88}"/>
-          </ac:spMkLst>
-        </pc:spChg>
-        <pc:spChg chg="add mod">
-          <ac:chgData name="Fatima Pillosu" userId="a6295d4dc9e22643" providerId="LiveId" clId="{87453732-75AC-4426-B5D3-B7C69C2D4F54}" dt="2026-01-20T00:06:27.992" v="144"/>
-          <ac:spMkLst>
-            <pc:docMk/>
-            <pc:sldMk cId="1573992039" sldId="256"/>
-            <ac:spMk id="840" creationId="{32FBFAAE-FDB5-9C28-E4FB-9767C60AD9AD}"/>
           </ac:spMkLst>
         </pc:spChg>
         <pc:spChg chg="del mod">
@@ -295,28 +431,12 @@
             <ac:spMk id="1046" creationId="{F4E1EB47-FB49-B221-8F40-6FAAC8188E34}"/>
           </ac:spMkLst>
         </pc:spChg>
-        <pc:spChg chg="add mod">
-          <ac:chgData name="Fatima Pillosu" userId="a6295d4dc9e22643" providerId="LiveId" clId="{87453732-75AC-4426-B5D3-B7C69C2D4F54}" dt="2026-01-20T00:06:27.992" v="144"/>
-          <ac:spMkLst>
-            <pc:docMk/>
-            <pc:sldMk cId="1573992039" sldId="256"/>
-            <ac:spMk id="1051" creationId="{0EB5DAC0-7D5E-19E0-EF75-D601AE5E3294}"/>
-          </ac:spMkLst>
-        </pc:spChg>
         <pc:spChg chg="add del mod">
           <ac:chgData name="Fatima Pillosu" userId="a6295d4dc9e22643" providerId="LiveId" clId="{87453732-75AC-4426-B5D3-B7C69C2D4F54}" dt="2026-01-26T22:53:08.620" v="150" actId="478"/>
           <ac:spMkLst>
             <pc:docMk/>
             <pc:sldMk cId="1573992039" sldId="256"/>
             <ac:spMk id="1052" creationId="{964EC952-07EF-AA5F-815E-D6BF5819DB79}"/>
-          </ac:spMkLst>
-        </pc:spChg>
-        <pc:spChg chg="add mod">
-          <ac:chgData name="Fatima Pillosu" userId="a6295d4dc9e22643" providerId="LiveId" clId="{87453732-75AC-4426-B5D3-B7C69C2D4F54}" dt="2026-01-20T00:06:27.992" v="144"/>
-          <ac:spMkLst>
-            <pc:docMk/>
-            <pc:sldMk cId="1573992039" sldId="256"/>
-            <ac:spMk id="1056" creationId="{6C660C77-D465-82E3-BFA2-7CB49265F32B}"/>
           </ac:spMkLst>
         </pc:spChg>
         <pc:spChg chg="mod">
@@ -367,14 +487,6 @@
             <ac:spMk id="1091" creationId="{0559E9B8-ED2A-B7C5-CD99-FCCACB55B247}"/>
           </ac:spMkLst>
         </pc:spChg>
-        <pc:spChg chg="add mod">
-          <ac:chgData name="Fatima Pillosu" userId="a6295d4dc9e22643" providerId="LiveId" clId="{87453732-75AC-4426-B5D3-B7C69C2D4F54}" dt="2026-01-20T00:06:27.992" v="144"/>
-          <ac:spMkLst>
-            <pc:docMk/>
-            <pc:sldMk cId="1573992039" sldId="256"/>
-            <ac:spMk id="1101" creationId="{AEF79955-9585-5CF1-C444-DDF210469501}"/>
-          </ac:spMkLst>
-        </pc:spChg>
         <pc:spChg chg="del mod">
           <ac:chgData name="Fatima Pillosu" userId="a6295d4dc9e22643" providerId="LiveId" clId="{87453732-75AC-4426-B5D3-B7C69C2D4F54}" dt="2026-01-26T22:56:09.237" v="241" actId="21"/>
           <ac:spMkLst>
@@ -423,14 +535,6 @@
             <ac:spMk id="1122" creationId="{4FB22F50-5C99-2B5F-1771-1D302FB37FCD}"/>
           </ac:spMkLst>
         </pc:spChg>
-        <pc:spChg chg="add mod">
-          <ac:chgData name="Fatima Pillosu" userId="a6295d4dc9e22643" providerId="LiveId" clId="{87453732-75AC-4426-B5D3-B7C69C2D4F54}" dt="2026-01-20T00:06:27.992" v="144"/>
-          <ac:spMkLst>
-            <pc:docMk/>
-            <pc:sldMk cId="1573992039" sldId="256"/>
-            <ac:spMk id="1124" creationId="{B7776DAF-AB8C-150D-9732-CC67560B199A}"/>
-          </ac:spMkLst>
-        </pc:spChg>
         <pc:spChg chg="del mod">
           <ac:chgData name="Fatima Pillosu" userId="a6295d4dc9e22643" providerId="LiveId" clId="{87453732-75AC-4426-B5D3-B7C69C2D4F54}" dt="2026-01-26T22:56:09.237" v="241" actId="21"/>
           <ac:spMkLst>
@@ -477,14 +581,6 @@
             <pc:docMk/>
             <pc:sldMk cId="1573992039" sldId="256"/>
             <ac:spMk id="1137" creationId="{282A075C-FC14-ED03-372D-F218BF14C255}"/>
-          </ac:spMkLst>
-        </pc:spChg>
-        <pc:spChg chg="add mod">
-          <ac:chgData name="Fatima Pillosu" userId="a6295d4dc9e22643" providerId="LiveId" clId="{87453732-75AC-4426-B5D3-B7C69C2D4F54}" dt="2026-01-20T00:06:27.992" v="144"/>
-          <ac:spMkLst>
-            <pc:docMk/>
-            <pc:sldMk cId="1573992039" sldId="256"/>
-            <ac:spMk id="1145" creationId="{0D756F47-6773-61EE-FBB2-2FD6EA2404A7}"/>
           </ac:spMkLst>
         </pc:spChg>
         <pc:spChg chg="del">
@@ -610,15 +706,15 @@
         </p:nvSpPr>
         <p:spPr>
           <a:xfrm>
-            <a:off x="517525" y="241620"/>
-            <a:ext cx="3105150" cy="513997"/>
+            <a:off x="517525" y="212002"/>
+            <a:ext cx="3105150" cy="450991"/>
           </a:xfrm>
         </p:spPr>
         <p:txBody>
           <a:bodyPr anchor="b"/>
           <a:lstStyle>
             <a:lvl1pPr algn="ctr">
-              <a:defRPr sz="1292"/>
+              <a:defRPr sz="1133"/>
             </a:lvl1pPr>
           </a:lstStyle>
           <a:p>
@@ -642,8 +738,8 @@
         </p:nvSpPr>
         <p:spPr>
           <a:xfrm>
-            <a:off x="517525" y="775439"/>
-            <a:ext cx="3105150" cy="356449"/>
+            <a:off x="517525" y="680385"/>
+            <a:ext cx="3105150" cy="312755"/>
           </a:xfrm>
         </p:spPr>
         <p:txBody>
@@ -651,39 +747,39 @@
           <a:lstStyle>
             <a:lvl1pPr marL="0" indent="0" algn="ctr">
               <a:buNone/>
-              <a:defRPr sz="517"/>
+              <a:defRPr sz="453"/>
             </a:lvl1pPr>
-            <a:lvl2pPr marL="98435" indent="0" algn="ctr">
+            <a:lvl2pPr marL="86365" indent="0" algn="ctr">
               <a:buNone/>
-              <a:defRPr sz="431"/>
+              <a:defRPr sz="378"/>
             </a:lvl2pPr>
-            <a:lvl3pPr marL="196870" indent="0" algn="ctr">
+            <a:lvl3pPr marL="172730" indent="0" algn="ctr">
               <a:buNone/>
-              <a:defRPr sz="388"/>
+              <a:defRPr sz="340"/>
             </a:lvl3pPr>
-            <a:lvl4pPr marL="295305" indent="0" algn="ctr">
+            <a:lvl4pPr marL="259095" indent="0" algn="ctr">
               <a:buNone/>
-              <a:defRPr sz="344"/>
+              <a:defRPr sz="302"/>
             </a:lvl4pPr>
-            <a:lvl5pPr marL="393741" indent="0" algn="ctr">
+            <a:lvl5pPr marL="345460" indent="0" algn="ctr">
               <a:buNone/>
-              <a:defRPr sz="344"/>
+              <a:defRPr sz="302"/>
             </a:lvl5pPr>
-            <a:lvl6pPr marL="492176" indent="0" algn="ctr">
+            <a:lvl6pPr marL="431825" indent="0" algn="ctr">
               <a:buNone/>
-              <a:defRPr sz="344"/>
+              <a:defRPr sz="302"/>
             </a:lvl6pPr>
-            <a:lvl7pPr marL="590611" indent="0" algn="ctr">
+            <a:lvl7pPr marL="518190" indent="0" algn="ctr">
               <a:buNone/>
-              <a:defRPr sz="344"/>
+              <a:defRPr sz="302"/>
             </a:lvl7pPr>
-            <a:lvl8pPr marL="689046" indent="0" algn="ctr">
+            <a:lvl8pPr marL="604556" indent="0" algn="ctr">
               <a:buNone/>
-              <a:defRPr sz="344"/>
+              <a:defRPr sz="302"/>
             </a:lvl8pPr>
-            <a:lvl9pPr marL="787481" indent="0" algn="ctr">
+            <a:lvl9pPr marL="690921" indent="0" algn="ctr">
               <a:buNone/>
-              <a:defRPr sz="344"/>
+              <a:defRPr sz="302"/>
             </a:lvl9pPr>
           </a:lstStyle>
           <a:p>
@@ -763,7 +859,7 @@
     </p:spTree>
     <p:extLst>
       <p:ext uri="{BB962C8B-B14F-4D97-AF65-F5344CB8AC3E}">
-        <p14:creationId xmlns:p14="http://schemas.microsoft.com/office/powerpoint/2010/main" val="485022592"/>
+        <p14:creationId xmlns:p14="http://schemas.microsoft.com/office/powerpoint/2010/main" val="168190780"/>
       </p:ext>
     </p:extLst>
   </p:cSld>
@@ -933,7 +1029,7 @@
     </p:spTree>
     <p:extLst>
       <p:ext uri="{BB962C8B-B14F-4D97-AF65-F5344CB8AC3E}">
-        <p14:creationId xmlns:p14="http://schemas.microsoft.com/office/powerpoint/2010/main" val="2881162985"/>
+        <p14:creationId xmlns:p14="http://schemas.microsoft.com/office/powerpoint/2010/main" val="2815616090"/>
       </p:ext>
     </p:extLst>
   </p:cSld>
@@ -972,8 +1068,8 @@
         </p:nvSpPr>
         <p:spPr>
           <a:xfrm>
-            <a:off x="2962830" y="78603"/>
-            <a:ext cx="892731" cy="1251160"/>
+            <a:off x="2962830" y="68968"/>
+            <a:ext cx="892731" cy="1097792"/>
           </a:xfrm>
         </p:spPr>
         <p:txBody>
@@ -1000,8 +1096,8 @@
         </p:nvSpPr>
         <p:spPr>
           <a:xfrm>
-            <a:off x="284639" y="78603"/>
-            <a:ext cx="2626439" cy="1251160"/>
+            <a:off x="284639" y="68968"/>
+            <a:ext cx="2626439" cy="1097792"/>
           </a:xfrm>
         </p:spPr>
         <p:txBody>
@@ -1113,7 +1209,7 @@
     </p:spTree>
     <p:extLst>
       <p:ext uri="{BB962C8B-B14F-4D97-AF65-F5344CB8AC3E}">
-        <p14:creationId xmlns:p14="http://schemas.microsoft.com/office/powerpoint/2010/main" val="3503419540"/>
+        <p14:creationId xmlns:p14="http://schemas.microsoft.com/office/powerpoint/2010/main" val="3496906896"/>
       </p:ext>
     </p:extLst>
   </p:cSld>
@@ -1283,7 +1379,7 @@
     </p:spTree>
     <p:extLst>
       <p:ext uri="{BB962C8B-B14F-4D97-AF65-F5344CB8AC3E}">
-        <p14:creationId xmlns:p14="http://schemas.microsoft.com/office/powerpoint/2010/main" val="1090233478"/>
+        <p14:creationId xmlns:p14="http://schemas.microsoft.com/office/powerpoint/2010/main" val="3145035884"/>
       </p:ext>
     </p:extLst>
   </p:cSld>
@@ -1322,15 +1418,15 @@
         </p:nvSpPr>
         <p:spPr>
           <a:xfrm>
-            <a:off x="282482" y="368069"/>
-            <a:ext cx="3570923" cy="614131"/>
+            <a:off x="282482" y="322951"/>
+            <a:ext cx="3570923" cy="538850"/>
           </a:xfrm>
         </p:spPr>
         <p:txBody>
           <a:bodyPr anchor="b"/>
           <a:lstStyle>
             <a:lvl1pPr>
-              <a:defRPr sz="1292"/>
+              <a:defRPr sz="1133"/>
             </a:lvl1pPr>
           </a:lstStyle>
           <a:p>
@@ -1354,8 +1450,8 @@
         </p:nvSpPr>
         <p:spPr>
           <a:xfrm>
-            <a:off x="282482" y="988009"/>
-            <a:ext cx="3570923" cy="322957"/>
+            <a:off x="282482" y="866898"/>
+            <a:ext cx="3570923" cy="283369"/>
           </a:xfrm>
         </p:spPr>
         <p:txBody>
@@ -1363,7 +1459,7 @@
           <a:lstStyle>
             <a:lvl1pPr marL="0" indent="0">
               <a:buNone/>
-              <a:defRPr sz="517">
+              <a:defRPr sz="453">
                 <a:solidFill>
                   <a:schemeClr val="tx1">
                     <a:tint val="82000"/>
@@ -1371,9 +1467,9 @@
                 </a:solidFill>
               </a:defRPr>
             </a:lvl1pPr>
-            <a:lvl2pPr marL="98435" indent="0">
+            <a:lvl2pPr marL="86365" indent="0">
               <a:buNone/>
-              <a:defRPr sz="431">
+              <a:defRPr sz="378">
                 <a:solidFill>
                   <a:schemeClr val="tx1">
                     <a:tint val="82000"/>
@@ -1381,9 +1477,9 @@
                 </a:solidFill>
               </a:defRPr>
             </a:lvl2pPr>
-            <a:lvl3pPr marL="196870" indent="0">
+            <a:lvl3pPr marL="172730" indent="0">
               <a:buNone/>
-              <a:defRPr sz="388">
+              <a:defRPr sz="340">
                 <a:solidFill>
                   <a:schemeClr val="tx1">
                     <a:tint val="82000"/>
@@ -1391,9 +1487,9 @@
                 </a:solidFill>
               </a:defRPr>
             </a:lvl3pPr>
-            <a:lvl4pPr marL="295305" indent="0">
+            <a:lvl4pPr marL="259095" indent="0">
               <a:buNone/>
-              <a:defRPr sz="344">
+              <a:defRPr sz="302">
                 <a:solidFill>
                   <a:schemeClr val="tx1">
                     <a:tint val="82000"/>
@@ -1401,9 +1497,9 @@
                 </a:solidFill>
               </a:defRPr>
             </a:lvl4pPr>
-            <a:lvl5pPr marL="393741" indent="0">
+            <a:lvl5pPr marL="345460" indent="0">
               <a:buNone/>
-              <a:defRPr sz="344">
+              <a:defRPr sz="302">
                 <a:solidFill>
                   <a:schemeClr val="tx1">
                     <a:tint val="82000"/>
@@ -1411,9 +1507,9 @@
                 </a:solidFill>
               </a:defRPr>
             </a:lvl5pPr>
-            <a:lvl6pPr marL="492176" indent="0">
+            <a:lvl6pPr marL="431825" indent="0">
               <a:buNone/>
-              <a:defRPr sz="344">
+              <a:defRPr sz="302">
                 <a:solidFill>
                   <a:schemeClr val="tx1">
                     <a:tint val="82000"/>
@@ -1421,9 +1517,9 @@
                 </a:solidFill>
               </a:defRPr>
             </a:lvl6pPr>
-            <a:lvl7pPr marL="590611" indent="0">
+            <a:lvl7pPr marL="518190" indent="0">
               <a:buNone/>
-              <a:defRPr sz="344">
+              <a:defRPr sz="302">
                 <a:solidFill>
                   <a:schemeClr val="tx1">
                     <a:tint val="82000"/>
@@ -1431,9 +1527,9 @@
                 </a:solidFill>
               </a:defRPr>
             </a:lvl7pPr>
-            <a:lvl8pPr marL="689046" indent="0">
+            <a:lvl8pPr marL="604556" indent="0">
               <a:buNone/>
-              <a:defRPr sz="344">
+              <a:defRPr sz="302">
                 <a:solidFill>
                   <a:schemeClr val="tx1">
                     <a:tint val="82000"/>
@@ -1441,9 +1537,9 @@
                 </a:solidFill>
               </a:defRPr>
             </a:lvl8pPr>
-            <a:lvl9pPr marL="787481" indent="0">
+            <a:lvl9pPr marL="690921" indent="0">
               <a:buNone/>
-              <a:defRPr sz="344">
+              <a:defRPr sz="302">
                 <a:solidFill>
                   <a:schemeClr val="tx1">
                     <a:tint val="82000"/>
@@ -1529,7 +1625,7 @@
     </p:spTree>
     <p:extLst>
       <p:ext uri="{BB962C8B-B14F-4D97-AF65-F5344CB8AC3E}">
-        <p14:creationId xmlns:p14="http://schemas.microsoft.com/office/powerpoint/2010/main" val="2389448510"/>
+        <p14:creationId xmlns:p14="http://schemas.microsoft.com/office/powerpoint/2010/main" val="2742547755"/>
       </p:ext>
     </p:extLst>
   </p:cSld>
@@ -1591,8 +1687,8 @@
         </p:nvSpPr>
         <p:spPr>
           <a:xfrm>
-            <a:off x="284639" y="393017"/>
-            <a:ext cx="1759585" cy="936746"/>
+            <a:off x="284639" y="344840"/>
+            <a:ext cx="1759585" cy="821919"/>
           </a:xfrm>
         </p:spPr>
         <p:txBody>
@@ -1648,8 +1744,8 @@
         </p:nvSpPr>
         <p:spPr>
           <a:xfrm>
-            <a:off x="2095976" y="393017"/>
-            <a:ext cx="1759585" cy="936746"/>
+            <a:off x="2095976" y="344840"/>
+            <a:ext cx="1759585" cy="821919"/>
           </a:xfrm>
         </p:spPr>
         <p:txBody>
@@ -1761,7 +1857,7 @@
     </p:spTree>
     <p:extLst>
       <p:ext uri="{BB962C8B-B14F-4D97-AF65-F5344CB8AC3E}">
-        <p14:creationId xmlns:p14="http://schemas.microsoft.com/office/powerpoint/2010/main" val="3378541718"/>
+        <p14:creationId xmlns:p14="http://schemas.microsoft.com/office/powerpoint/2010/main" val="298216588"/>
       </p:ext>
     </p:extLst>
   </p:cSld>
@@ -1800,8 +1896,8 @@
         </p:nvSpPr>
         <p:spPr>
           <a:xfrm>
-            <a:off x="285178" y="78604"/>
-            <a:ext cx="3570923" cy="285364"/>
+            <a:off x="285178" y="68968"/>
+            <a:ext cx="3570923" cy="250384"/>
           </a:xfrm>
         </p:spPr>
         <p:txBody>
@@ -1828,8 +1924,8 @@
         </p:nvSpPr>
         <p:spPr>
           <a:xfrm>
-            <a:off x="285178" y="361917"/>
-            <a:ext cx="1751499" cy="177370"/>
+            <a:off x="285178" y="317553"/>
+            <a:ext cx="1751499" cy="155628"/>
           </a:xfrm>
         </p:spPr>
         <p:txBody>
@@ -1837,39 +1933,39 @@
           <a:lstStyle>
             <a:lvl1pPr marL="0" indent="0">
               <a:buNone/>
-              <a:defRPr sz="517" b="1"/>
+              <a:defRPr sz="453" b="1"/>
             </a:lvl1pPr>
-            <a:lvl2pPr marL="98435" indent="0">
+            <a:lvl2pPr marL="86365" indent="0">
               <a:buNone/>
-              <a:defRPr sz="431" b="1"/>
+              <a:defRPr sz="378" b="1"/>
             </a:lvl2pPr>
-            <a:lvl3pPr marL="196870" indent="0">
+            <a:lvl3pPr marL="172730" indent="0">
               <a:buNone/>
-              <a:defRPr sz="388" b="1"/>
+              <a:defRPr sz="340" b="1"/>
             </a:lvl3pPr>
-            <a:lvl4pPr marL="295305" indent="0">
+            <a:lvl4pPr marL="259095" indent="0">
               <a:buNone/>
-              <a:defRPr sz="344" b="1"/>
+              <a:defRPr sz="302" b="1"/>
             </a:lvl4pPr>
-            <a:lvl5pPr marL="393741" indent="0">
+            <a:lvl5pPr marL="345460" indent="0">
               <a:buNone/>
-              <a:defRPr sz="344" b="1"/>
+              <a:defRPr sz="302" b="1"/>
             </a:lvl5pPr>
-            <a:lvl6pPr marL="492176" indent="0">
+            <a:lvl6pPr marL="431825" indent="0">
               <a:buNone/>
-              <a:defRPr sz="344" b="1"/>
+              <a:defRPr sz="302" b="1"/>
             </a:lvl6pPr>
-            <a:lvl7pPr marL="590611" indent="0">
+            <a:lvl7pPr marL="518190" indent="0">
               <a:buNone/>
-              <a:defRPr sz="344" b="1"/>
+              <a:defRPr sz="302" b="1"/>
             </a:lvl7pPr>
-            <a:lvl8pPr marL="689046" indent="0">
+            <a:lvl8pPr marL="604556" indent="0">
               <a:buNone/>
-              <a:defRPr sz="344" b="1"/>
+              <a:defRPr sz="302" b="1"/>
             </a:lvl8pPr>
-            <a:lvl9pPr marL="787481" indent="0">
+            <a:lvl9pPr marL="690921" indent="0">
               <a:buNone/>
-              <a:defRPr sz="344" b="1"/>
+              <a:defRPr sz="302" b="1"/>
             </a:lvl9pPr>
           </a:lstStyle>
           <a:p>
@@ -1893,8 +1989,8 @@
         </p:nvSpPr>
         <p:spPr>
           <a:xfrm>
-            <a:off x="285178" y="539287"/>
-            <a:ext cx="1751499" cy="793210"/>
+            <a:off x="285178" y="473181"/>
+            <a:ext cx="1751499" cy="695978"/>
           </a:xfrm>
         </p:spPr>
         <p:txBody>
@@ -1950,8 +2046,8 @@
         </p:nvSpPr>
         <p:spPr>
           <a:xfrm>
-            <a:off x="2095976" y="361917"/>
-            <a:ext cx="1760124" cy="177370"/>
+            <a:off x="2095976" y="317553"/>
+            <a:ext cx="1760124" cy="155628"/>
           </a:xfrm>
         </p:spPr>
         <p:txBody>
@@ -1959,39 +2055,39 @@
           <a:lstStyle>
             <a:lvl1pPr marL="0" indent="0">
               <a:buNone/>
-              <a:defRPr sz="517" b="1"/>
+              <a:defRPr sz="453" b="1"/>
             </a:lvl1pPr>
-            <a:lvl2pPr marL="98435" indent="0">
+            <a:lvl2pPr marL="86365" indent="0">
               <a:buNone/>
-              <a:defRPr sz="431" b="1"/>
+              <a:defRPr sz="378" b="1"/>
             </a:lvl2pPr>
-            <a:lvl3pPr marL="196870" indent="0">
+            <a:lvl3pPr marL="172730" indent="0">
               <a:buNone/>
-              <a:defRPr sz="388" b="1"/>
+              <a:defRPr sz="340" b="1"/>
             </a:lvl3pPr>
-            <a:lvl4pPr marL="295305" indent="0">
+            <a:lvl4pPr marL="259095" indent="0">
               <a:buNone/>
-              <a:defRPr sz="344" b="1"/>
+              <a:defRPr sz="302" b="1"/>
             </a:lvl4pPr>
-            <a:lvl5pPr marL="393741" indent="0">
+            <a:lvl5pPr marL="345460" indent="0">
               <a:buNone/>
-              <a:defRPr sz="344" b="1"/>
+              <a:defRPr sz="302" b="1"/>
             </a:lvl5pPr>
-            <a:lvl6pPr marL="492176" indent="0">
+            <a:lvl6pPr marL="431825" indent="0">
               <a:buNone/>
-              <a:defRPr sz="344" b="1"/>
+              <a:defRPr sz="302" b="1"/>
             </a:lvl6pPr>
-            <a:lvl7pPr marL="590611" indent="0">
+            <a:lvl7pPr marL="518190" indent="0">
               <a:buNone/>
-              <a:defRPr sz="344" b="1"/>
+              <a:defRPr sz="302" b="1"/>
             </a:lvl7pPr>
-            <a:lvl8pPr marL="689046" indent="0">
+            <a:lvl8pPr marL="604556" indent="0">
               <a:buNone/>
-              <a:defRPr sz="344" b="1"/>
+              <a:defRPr sz="302" b="1"/>
             </a:lvl8pPr>
-            <a:lvl9pPr marL="787481" indent="0">
+            <a:lvl9pPr marL="690921" indent="0">
               <a:buNone/>
-              <a:defRPr sz="344" b="1"/>
+              <a:defRPr sz="302" b="1"/>
             </a:lvl9pPr>
           </a:lstStyle>
           <a:p>
@@ -2015,8 +2111,8 @@
         </p:nvSpPr>
         <p:spPr>
           <a:xfrm>
-            <a:off x="2095976" y="539287"/>
-            <a:ext cx="1760124" cy="793210"/>
+            <a:off x="2095976" y="473181"/>
+            <a:ext cx="1760124" cy="695978"/>
           </a:xfrm>
         </p:spPr>
         <p:txBody>
@@ -2128,7 +2224,7 @@
     </p:spTree>
     <p:extLst>
       <p:ext uri="{BB962C8B-B14F-4D97-AF65-F5344CB8AC3E}">
-        <p14:creationId xmlns:p14="http://schemas.microsoft.com/office/powerpoint/2010/main" val="534525737"/>
+        <p14:creationId xmlns:p14="http://schemas.microsoft.com/office/powerpoint/2010/main" val="4067022621"/>
       </p:ext>
     </p:extLst>
   </p:cSld>
@@ -2246,7 +2342,7 @@
     </p:spTree>
     <p:extLst>
       <p:ext uri="{BB962C8B-B14F-4D97-AF65-F5344CB8AC3E}">
-        <p14:creationId xmlns:p14="http://schemas.microsoft.com/office/powerpoint/2010/main" val="4287672826"/>
+        <p14:creationId xmlns:p14="http://schemas.microsoft.com/office/powerpoint/2010/main" val="1269084545"/>
       </p:ext>
     </p:extLst>
   </p:cSld>
@@ -2341,7 +2437,7 @@
     </p:spTree>
     <p:extLst>
       <p:ext uri="{BB962C8B-B14F-4D97-AF65-F5344CB8AC3E}">
-        <p14:creationId xmlns:p14="http://schemas.microsoft.com/office/powerpoint/2010/main" val="1559577475"/>
+        <p14:creationId xmlns:p14="http://schemas.microsoft.com/office/powerpoint/2010/main" val="1213821683"/>
       </p:ext>
     </p:extLst>
   </p:cSld>
@@ -2380,15 +2476,15 @@
         </p:nvSpPr>
         <p:spPr>
           <a:xfrm>
-            <a:off x="285178" y="98425"/>
-            <a:ext cx="1335322" cy="344488"/>
+            <a:off x="285178" y="86360"/>
+            <a:ext cx="1335322" cy="302260"/>
           </a:xfrm>
         </p:spPr>
         <p:txBody>
           <a:bodyPr anchor="b"/>
           <a:lstStyle>
             <a:lvl1pPr>
-              <a:defRPr sz="689"/>
+              <a:defRPr sz="604"/>
             </a:lvl1pPr>
           </a:lstStyle>
           <a:p>
@@ -2412,39 +2508,39 @@
         </p:nvSpPr>
         <p:spPr>
           <a:xfrm>
-            <a:off x="1760124" y="212571"/>
-            <a:ext cx="2095976" cy="1049183"/>
+            <a:off x="1760124" y="186514"/>
+            <a:ext cx="2095976" cy="920574"/>
           </a:xfrm>
         </p:spPr>
         <p:txBody>
           <a:bodyPr/>
           <a:lstStyle>
             <a:lvl1pPr>
-              <a:defRPr sz="689"/>
+              <a:defRPr sz="604"/>
             </a:lvl1pPr>
             <a:lvl2pPr>
-              <a:defRPr sz="603"/>
+              <a:defRPr sz="529"/>
             </a:lvl2pPr>
             <a:lvl3pPr>
-              <a:defRPr sz="517"/>
+              <a:defRPr sz="453"/>
             </a:lvl3pPr>
             <a:lvl4pPr>
-              <a:defRPr sz="431"/>
+              <a:defRPr sz="378"/>
             </a:lvl4pPr>
             <a:lvl5pPr>
-              <a:defRPr sz="431"/>
+              <a:defRPr sz="378"/>
             </a:lvl5pPr>
             <a:lvl6pPr>
-              <a:defRPr sz="431"/>
+              <a:defRPr sz="378"/>
             </a:lvl6pPr>
             <a:lvl7pPr>
-              <a:defRPr sz="431"/>
+              <a:defRPr sz="378"/>
             </a:lvl7pPr>
             <a:lvl8pPr>
-              <a:defRPr sz="431"/>
+              <a:defRPr sz="378"/>
             </a:lvl8pPr>
             <a:lvl9pPr>
-              <a:defRPr sz="431"/>
+              <a:defRPr sz="378"/>
             </a:lvl9pPr>
           </a:lstStyle>
           <a:p>
@@ -2497,8 +2593,8 @@
         </p:nvSpPr>
         <p:spPr>
           <a:xfrm>
-            <a:off x="285178" y="442913"/>
-            <a:ext cx="1335322" cy="820550"/>
+            <a:off x="285178" y="388620"/>
+            <a:ext cx="1335322" cy="719967"/>
           </a:xfrm>
         </p:spPr>
         <p:txBody>
@@ -2506,39 +2602,39 @@
           <a:lstStyle>
             <a:lvl1pPr marL="0" indent="0">
               <a:buNone/>
-              <a:defRPr sz="344"/>
+              <a:defRPr sz="302"/>
             </a:lvl1pPr>
-            <a:lvl2pPr marL="98435" indent="0">
+            <a:lvl2pPr marL="86365" indent="0">
               <a:buNone/>
-              <a:defRPr sz="301"/>
+              <a:defRPr sz="264"/>
             </a:lvl2pPr>
-            <a:lvl3pPr marL="196870" indent="0">
+            <a:lvl3pPr marL="172730" indent="0">
               <a:buNone/>
-              <a:defRPr sz="258"/>
+              <a:defRPr sz="227"/>
             </a:lvl3pPr>
-            <a:lvl4pPr marL="295305" indent="0">
+            <a:lvl4pPr marL="259095" indent="0">
               <a:buNone/>
-              <a:defRPr sz="215"/>
+              <a:defRPr sz="189"/>
             </a:lvl4pPr>
-            <a:lvl5pPr marL="393741" indent="0">
+            <a:lvl5pPr marL="345460" indent="0">
               <a:buNone/>
-              <a:defRPr sz="215"/>
+              <a:defRPr sz="189"/>
             </a:lvl5pPr>
-            <a:lvl6pPr marL="492176" indent="0">
+            <a:lvl6pPr marL="431825" indent="0">
               <a:buNone/>
-              <a:defRPr sz="215"/>
+              <a:defRPr sz="189"/>
             </a:lvl6pPr>
-            <a:lvl7pPr marL="590611" indent="0">
+            <a:lvl7pPr marL="518190" indent="0">
               <a:buNone/>
-              <a:defRPr sz="215"/>
+              <a:defRPr sz="189"/>
             </a:lvl7pPr>
-            <a:lvl8pPr marL="689046" indent="0">
+            <a:lvl8pPr marL="604556" indent="0">
               <a:buNone/>
-              <a:defRPr sz="215"/>
+              <a:defRPr sz="189"/>
             </a:lvl8pPr>
-            <a:lvl9pPr marL="787481" indent="0">
+            <a:lvl9pPr marL="690921" indent="0">
               <a:buNone/>
-              <a:defRPr sz="215"/>
+              <a:defRPr sz="189"/>
             </a:lvl9pPr>
           </a:lstStyle>
           <a:p>
@@ -2618,7 +2714,7 @@
     </p:spTree>
     <p:extLst>
       <p:ext uri="{BB962C8B-B14F-4D97-AF65-F5344CB8AC3E}">
-        <p14:creationId xmlns:p14="http://schemas.microsoft.com/office/powerpoint/2010/main" val="3575580695"/>
+        <p14:creationId xmlns:p14="http://schemas.microsoft.com/office/powerpoint/2010/main" val="4023084415"/>
       </p:ext>
     </p:extLst>
   </p:cSld>
@@ -2657,15 +2753,15 @@
         </p:nvSpPr>
         <p:spPr>
           <a:xfrm>
-            <a:off x="285178" y="98425"/>
-            <a:ext cx="1335322" cy="344488"/>
+            <a:off x="285178" y="86360"/>
+            <a:ext cx="1335322" cy="302260"/>
           </a:xfrm>
         </p:spPr>
         <p:txBody>
           <a:bodyPr anchor="b"/>
           <a:lstStyle>
             <a:lvl1pPr>
-              <a:defRPr sz="689"/>
+              <a:defRPr sz="604"/>
             </a:lvl1pPr>
           </a:lstStyle>
           <a:p>
@@ -2689,8 +2785,8 @@
         </p:nvSpPr>
         <p:spPr>
           <a:xfrm>
-            <a:off x="1760124" y="212571"/>
-            <a:ext cx="2095976" cy="1049183"/>
+            <a:off x="1760124" y="186514"/>
+            <a:ext cx="2095976" cy="920574"/>
           </a:xfrm>
         </p:spPr>
         <p:txBody>
@@ -2698,39 +2794,39 @@
           <a:lstStyle>
             <a:lvl1pPr marL="0" indent="0">
               <a:buNone/>
-              <a:defRPr sz="689"/>
+              <a:defRPr sz="604"/>
             </a:lvl1pPr>
-            <a:lvl2pPr marL="98435" indent="0">
+            <a:lvl2pPr marL="86365" indent="0">
               <a:buNone/>
-              <a:defRPr sz="603"/>
+              <a:defRPr sz="529"/>
             </a:lvl2pPr>
-            <a:lvl3pPr marL="196870" indent="0">
+            <a:lvl3pPr marL="172730" indent="0">
               <a:buNone/>
-              <a:defRPr sz="517"/>
+              <a:defRPr sz="453"/>
             </a:lvl3pPr>
-            <a:lvl4pPr marL="295305" indent="0">
+            <a:lvl4pPr marL="259095" indent="0">
               <a:buNone/>
-              <a:defRPr sz="431"/>
+              <a:defRPr sz="378"/>
             </a:lvl4pPr>
-            <a:lvl5pPr marL="393741" indent="0">
+            <a:lvl5pPr marL="345460" indent="0">
               <a:buNone/>
-              <a:defRPr sz="431"/>
+              <a:defRPr sz="378"/>
             </a:lvl5pPr>
-            <a:lvl6pPr marL="492176" indent="0">
+            <a:lvl6pPr marL="431825" indent="0">
               <a:buNone/>
-              <a:defRPr sz="431"/>
+              <a:defRPr sz="378"/>
             </a:lvl6pPr>
-            <a:lvl7pPr marL="590611" indent="0">
+            <a:lvl7pPr marL="518190" indent="0">
               <a:buNone/>
-              <a:defRPr sz="431"/>
+              <a:defRPr sz="378"/>
             </a:lvl7pPr>
-            <a:lvl8pPr marL="689046" indent="0">
+            <a:lvl8pPr marL="604556" indent="0">
               <a:buNone/>
-              <a:defRPr sz="431"/>
+              <a:defRPr sz="378"/>
             </a:lvl8pPr>
-            <a:lvl9pPr marL="787481" indent="0">
+            <a:lvl9pPr marL="690921" indent="0">
               <a:buNone/>
-              <a:defRPr sz="431"/>
+              <a:defRPr sz="378"/>
             </a:lvl9pPr>
           </a:lstStyle>
           <a:p>
@@ -2754,8 +2850,8 @@
         </p:nvSpPr>
         <p:spPr>
           <a:xfrm>
-            <a:off x="285178" y="442913"/>
-            <a:ext cx="1335322" cy="820550"/>
+            <a:off x="285178" y="388620"/>
+            <a:ext cx="1335322" cy="719967"/>
           </a:xfrm>
         </p:spPr>
         <p:txBody>
@@ -2763,39 +2859,39 @@
           <a:lstStyle>
             <a:lvl1pPr marL="0" indent="0">
               <a:buNone/>
-              <a:defRPr sz="344"/>
+              <a:defRPr sz="302"/>
             </a:lvl1pPr>
-            <a:lvl2pPr marL="98435" indent="0">
+            <a:lvl2pPr marL="86365" indent="0">
               <a:buNone/>
-              <a:defRPr sz="301"/>
+              <a:defRPr sz="264"/>
             </a:lvl2pPr>
-            <a:lvl3pPr marL="196870" indent="0">
+            <a:lvl3pPr marL="172730" indent="0">
               <a:buNone/>
-              <a:defRPr sz="258"/>
+              <a:defRPr sz="227"/>
             </a:lvl3pPr>
-            <a:lvl4pPr marL="295305" indent="0">
+            <a:lvl4pPr marL="259095" indent="0">
               <a:buNone/>
-              <a:defRPr sz="215"/>
+              <a:defRPr sz="189"/>
             </a:lvl4pPr>
-            <a:lvl5pPr marL="393741" indent="0">
+            <a:lvl5pPr marL="345460" indent="0">
               <a:buNone/>
-              <a:defRPr sz="215"/>
+              <a:defRPr sz="189"/>
             </a:lvl5pPr>
-            <a:lvl6pPr marL="492176" indent="0">
+            <a:lvl6pPr marL="431825" indent="0">
               <a:buNone/>
-              <a:defRPr sz="215"/>
+              <a:defRPr sz="189"/>
             </a:lvl6pPr>
-            <a:lvl7pPr marL="590611" indent="0">
+            <a:lvl7pPr marL="518190" indent="0">
               <a:buNone/>
-              <a:defRPr sz="215"/>
+              <a:defRPr sz="189"/>
             </a:lvl7pPr>
-            <a:lvl8pPr marL="689046" indent="0">
+            <a:lvl8pPr marL="604556" indent="0">
               <a:buNone/>
-              <a:defRPr sz="215"/>
+              <a:defRPr sz="189"/>
             </a:lvl8pPr>
-            <a:lvl9pPr marL="787481" indent="0">
+            <a:lvl9pPr marL="690921" indent="0">
               <a:buNone/>
-              <a:defRPr sz="215"/>
+              <a:defRPr sz="189"/>
             </a:lvl9pPr>
           </a:lstStyle>
           <a:p>
@@ -2875,7 +2971,7 @@
     </p:spTree>
     <p:extLst>
       <p:ext uri="{BB962C8B-B14F-4D97-AF65-F5344CB8AC3E}">
-        <p14:creationId xmlns:p14="http://schemas.microsoft.com/office/powerpoint/2010/main" val="3812249120"/>
+        <p14:creationId xmlns:p14="http://schemas.microsoft.com/office/powerpoint/2010/main" val="3452765416"/>
       </p:ext>
     </p:extLst>
   </p:cSld>
@@ -2919,8 +3015,8 @@
         </p:nvSpPr>
         <p:spPr>
           <a:xfrm>
-            <a:off x="284639" y="78604"/>
-            <a:ext cx="3570923" cy="285364"/>
+            <a:off x="284639" y="68968"/>
+            <a:ext cx="3570923" cy="250384"/>
           </a:xfrm>
           <a:prstGeom prst="rect">
             <a:avLst/>
@@ -2952,8 +3048,8 @@
         </p:nvSpPr>
         <p:spPr>
           <a:xfrm>
-            <a:off x="284639" y="393017"/>
-            <a:ext cx="3570923" cy="936746"/>
+            <a:off x="284639" y="344840"/>
+            <a:ext cx="3570923" cy="821919"/>
           </a:xfrm>
           <a:prstGeom prst="rect">
             <a:avLst/>
@@ -3014,8 +3110,8 @@
         </p:nvSpPr>
         <p:spPr>
           <a:xfrm>
-            <a:off x="284639" y="1368381"/>
-            <a:ext cx="931545" cy="78603"/>
+            <a:off x="284639" y="1200644"/>
+            <a:ext cx="931545" cy="68968"/>
           </a:xfrm>
           <a:prstGeom prst="rect">
             <a:avLst/>
@@ -3025,7 +3121,7 @@
           <a:bodyPr vert="horz" lIns="91440" tIns="45720" rIns="91440" bIns="45720" rtlCol="0" anchor="ctr"/>
           <a:lstStyle>
             <a:lvl1pPr algn="l">
-              <a:defRPr sz="258">
+              <a:defRPr sz="227">
                 <a:solidFill>
                   <a:schemeClr val="tx1">
                     <a:tint val="82000"/>
@@ -3055,8 +3151,8 @@
         </p:nvSpPr>
         <p:spPr>
           <a:xfrm>
-            <a:off x="1371441" y="1368381"/>
-            <a:ext cx="1397318" cy="78603"/>
+            <a:off x="1371441" y="1200644"/>
+            <a:ext cx="1397318" cy="68968"/>
           </a:xfrm>
           <a:prstGeom prst="rect">
             <a:avLst/>
@@ -3066,7 +3162,7 @@
           <a:bodyPr vert="horz" lIns="91440" tIns="45720" rIns="91440" bIns="45720" rtlCol="0" anchor="ctr"/>
           <a:lstStyle>
             <a:lvl1pPr algn="ctr">
-              <a:defRPr sz="258">
+              <a:defRPr sz="227">
                 <a:solidFill>
                   <a:schemeClr val="tx1">
                     <a:tint val="82000"/>
@@ -3092,8 +3188,8 @@
         </p:nvSpPr>
         <p:spPr>
           <a:xfrm>
-            <a:off x="2924016" y="1368381"/>
-            <a:ext cx="931545" cy="78603"/>
+            <a:off x="2924016" y="1200644"/>
+            <a:ext cx="931545" cy="68968"/>
           </a:xfrm>
           <a:prstGeom prst="rect">
             <a:avLst/>
@@ -3103,7 +3199,7 @@
           <a:bodyPr vert="horz" lIns="91440" tIns="45720" rIns="91440" bIns="45720" rtlCol="0" anchor="ctr"/>
           <a:lstStyle>
             <a:lvl1pPr algn="r">
-              <a:defRPr sz="258">
+              <a:defRPr sz="227">
                 <a:solidFill>
                   <a:schemeClr val="tx1">
                     <a:tint val="82000"/>
@@ -3124,27 +3220,27 @@
     </p:spTree>
     <p:extLst>
       <p:ext uri="{BB962C8B-B14F-4D97-AF65-F5344CB8AC3E}">
-        <p14:creationId xmlns:p14="http://schemas.microsoft.com/office/powerpoint/2010/main" val="3992564974"/>
+        <p14:creationId xmlns:p14="http://schemas.microsoft.com/office/powerpoint/2010/main" val="157532977"/>
       </p:ext>
     </p:extLst>
   </p:cSld>
   <p:clrMap bg1="lt1" tx1="dk1" bg2="lt2" tx2="dk2" accent1="accent1" accent2="accent2" accent3="accent3" accent4="accent4" accent5="accent5" accent6="accent6" hlink="hlink" folHlink="folHlink"/>
   <p:sldLayoutIdLst>
-    <p:sldLayoutId id="2147483757" r:id="rId1"/>
-    <p:sldLayoutId id="2147483758" r:id="rId2"/>
-    <p:sldLayoutId id="2147483759" r:id="rId3"/>
-    <p:sldLayoutId id="2147483760" r:id="rId4"/>
-    <p:sldLayoutId id="2147483761" r:id="rId5"/>
-    <p:sldLayoutId id="2147483762" r:id="rId6"/>
-    <p:sldLayoutId id="2147483763" r:id="rId7"/>
-    <p:sldLayoutId id="2147483764" r:id="rId8"/>
-    <p:sldLayoutId id="2147483765" r:id="rId9"/>
-    <p:sldLayoutId id="2147483766" r:id="rId10"/>
-    <p:sldLayoutId id="2147483767" r:id="rId11"/>
+    <p:sldLayoutId id="2147483769" r:id="rId1"/>
+    <p:sldLayoutId id="2147483770" r:id="rId2"/>
+    <p:sldLayoutId id="2147483771" r:id="rId3"/>
+    <p:sldLayoutId id="2147483772" r:id="rId4"/>
+    <p:sldLayoutId id="2147483773" r:id="rId5"/>
+    <p:sldLayoutId id="2147483774" r:id="rId6"/>
+    <p:sldLayoutId id="2147483775" r:id="rId7"/>
+    <p:sldLayoutId id="2147483776" r:id="rId8"/>
+    <p:sldLayoutId id="2147483777" r:id="rId9"/>
+    <p:sldLayoutId id="2147483778" r:id="rId10"/>
+    <p:sldLayoutId id="2147483779" r:id="rId11"/>
   </p:sldLayoutIdLst>
   <p:txStyles>
     <p:titleStyle>
-      <a:lvl1pPr algn="l" defTabSz="196870" rtl="0" eaLnBrk="1" latinLnBrk="0" hangingPunct="1">
+      <a:lvl1pPr algn="l" defTabSz="172730" rtl="0" eaLnBrk="1" latinLnBrk="0" hangingPunct="1">
         <a:lnSpc>
           <a:spcPct val="90000"/>
         </a:lnSpc>
@@ -3152,7 +3248,7 @@
           <a:spcPct val="0"/>
         </a:spcBef>
         <a:buNone/>
-        <a:defRPr sz="947" kern="1200">
+        <a:defRPr sz="831" kern="1200">
           <a:solidFill>
             <a:schemeClr val="tx1"/>
           </a:solidFill>
@@ -3163,16 +3259,16 @@
       </a:lvl1pPr>
     </p:titleStyle>
     <p:bodyStyle>
-      <a:lvl1pPr marL="49218" indent="-49218" algn="l" defTabSz="196870" rtl="0" eaLnBrk="1" latinLnBrk="0" hangingPunct="1">
+      <a:lvl1pPr marL="43183" indent="-43183" algn="l" defTabSz="172730" rtl="0" eaLnBrk="1" latinLnBrk="0" hangingPunct="1">
         <a:lnSpc>
           <a:spcPct val="90000"/>
         </a:lnSpc>
         <a:spcBef>
-          <a:spcPts val="215"/>
+          <a:spcPts val="189"/>
         </a:spcBef>
         <a:buFont typeface="Arial" panose="020B0604020202020204" pitchFamily="34" charset="0"/>
         <a:buChar char="•"/>
-        <a:defRPr sz="603" kern="1200">
+        <a:defRPr sz="529" kern="1200">
           <a:solidFill>
             <a:schemeClr val="tx1"/>
           </a:solidFill>
@@ -3181,16 +3277,16 @@
           <a:cs typeface="+mn-cs"/>
         </a:defRPr>
       </a:lvl1pPr>
-      <a:lvl2pPr marL="147653" indent="-49218" algn="l" defTabSz="196870" rtl="0" eaLnBrk="1" latinLnBrk="0" hangingPunct="1">
+      <a:lvl2pPr marL="129548" indent="-43183" algn="l" defTabSz="172730" rtl="0" eaLnBrk="1" latinLnBrk="0" hangingPunct="1">
         <a:lnSpc>
           <a:spcPct val="90000"/>
         </a:lnSpc>
         <a:spcBef>
-          <a:spcPts val="108"/>
+          <a:spcPts val="94"/>
         </a:spcBef>
         <a:buFont typeface="Arial" panose="020B0604020202020204" pitchFamily="34" charset="0"/>
         <a:buChar char="•"/>
-        <a:defRPr sz="517" kern="1200">
+        <a:defRPr sz="453" kern="1200">
           <a:solidFill>
             <a:schemeClr val="tx1"/>
           </a:solidFill>
@@ -3199,16 +3295,16 @@
           <a:cs typeface="+mn-cs"/>
         </a:defRPr>
       </a:lvl2pPr>
-      <a:lvl3pPr marL="246088" indent="-49218" algn="l" defTabSz="196870" rtl="0" eaLnBrk="1" latinLnBrk="0" hangingPunct="1">
+      <a:lvl3pPr marL="215913" indent="-43183" algn="l" defTabSz="172730" rtl="0" eaLnBrk="1" latinLnBrk="0" hangingPunct="1">
         <a:lnSpc>
           <a:spcPct val="90000"/>
         </a:lnSpc>
         <a:spcBef>
-          <a:spcPts val="108"/>
+          <a:spcPts val="94"/>
         </a:spcBef>
         <a:buFont typeface="Arial" panose="020B0604020202020204" pitchFamily="34" charset="0"/>
         <a:buChar char="•"/>
-        <a:defRPr sz="431" kern="1200">
+        <a:defRPr sz="378" kern="1200">
           <a:solidFill>
             <a:schemeClr val="tx1"/>
           </a:solidFill>
@@ -3217,16 +3313,16 @@
           <a:cs typeface="+mn-cs"/>
         </a:defRPr>
       </a:lvl3pPr>
-      <a:lvl4pPr marL="344523" indent="-49218" algn="l" defTabSz="196870" rtl="0" eaLnBrk="1" latinLnBrk="0" hangingPunct="1">
+      <a:lvl4pPr marL="302278" indent="-43183" algn="l" defTabSz="172730" rtl="0" eaLnBrk="1" latinLnBrk="0" hangingPunct="1">
         <a:lnSpc>
           <a:spcPct val="90000"/>
         </a:lnSpc>
         <a:spcBef>
-          <a:spcPts val="108"/>
+          <a:spcPts val="94"/>
         </a:spcBef>
         <a:buFont typeface="Arial" panose="020B0604020202020204" pitchFamily="34" charset="0"/>
         <a:buChar char="•"/>
-        <a:defRPr sz="388" kern="1200">
+        <a:defRPr sz="340" kern="1200">
           <a:solidFill>
             <a:schemeClr val="tx1"/>
           </a:solidFill>
@@ -3235,16 +3331,16 @@
           <a:cs typeface="+mn-cs"/>
         </a:defRPr>
       </a:lvl4pPr>
-      <a:lvl5pPr marL="442958" indent="-49218" algn="l" defTabSz="196870" rtl="0" eaLnBrk="1" latinLnBrk="0" hangingPunct="1">
+      <a:lvl5pPr marL="388643" indent="-43183" algn="l" defTabSz="172730" rtl="0" eaLnBrk="1" latinLnBrk="0" hangingPunct="1">
         <a:lnSpc>
           <a:spcPct val="90000"/>
         </a:lnSpc>
         <a:spcBef>
-          <a:spcPts val="108"/>
+          <a:spcPts val="94"/>
         </a:spcBef>
         <a:buFont typeface="Arial" panose="020B0604020202020204" pitchFamily="34" charset="0"/>
         <a:buChar char="•"/>
-        <a:defRPr sz="388" kern="1200">
+        <a:defRPr sz="340" kern="1200">
           <a:solidFill>
             <a:schemeClr val="tx1"/>
           </a:solidFill>
@@ -3253,16 +3349,16 @@
           <a:cs typeface="+mn-cs"/>
         </a:defRPr>
       </a:lvl5pPr>
-      <a:lvl6pPr marL="541393" indent="-49218" algn="l" defTabSz="196870" rtl="0" eaLnBrk="1" latinLnBrk="0" hangingPunct="1">
+      <a:lvl6pPr marL="475008" indent="-43183" algn="l" defTabSz="172730" rtl="0" eaLnBrk="1" latinLnBrk="0" hangingPunct="1">
         <a:lnSpc>
           <a:spcPct val="90000"/>
         </a:lnSpc>
         <a:spcBef>
-          <a:spcPts val="108"/>
+          <a:spcPts val="94"/>
         </a:spcBef>
         <a:buFont typeface="Arial" panose="020B0604020202020204" pitchFamily="34" charset="0"/>
         <a:buChar char="•"/>
-        <a:defRPr sz="388" kern="1200">
+        <a:defRPr sz="340" kern="1200">
           <a:solidFill>
             <a:schemeClr val="tx1"/>
           </a:solidFill>
@@ -3271,16 +3367,16 @@
           <a:cs typeface="+mn-cs"/>
         </a:defRPr>
       </a:lvl6pPr>
-      <a:lvl7pPr marL="639829" indent="-49218" algn="l" defTabSz="196870" rtl="0" eaLnBrk="1" latinLnBrk="0" hangingPunct="1">
+      <a:lvl7pPr marL="561373" indent="-43183" algn="l" defTabSz="172730" rtl="0" eaLnBrk="1" latinLnBrk="0" hangingPunct="1">
         <a:lnSpc>
           <a:spcPct val="90000"/>
         </a:lnSpc>
         <a:spcBef>
-          <a:spcPts val="108"/>
+          <a:spcPts val="94"/>
         </a:spcBef>
         <a:buFont typeface="Arial" panose="020B0604020202020204" pitchFamily="34" charset="0"/>
         <a:buChar char="•"/>
-        <a:defRPr sz="388" kern="1200">
+        <a:defRPr sz="340" kern="1200">
           <a:solidFill>
             <a:schemeClr val="tx1"/>
           </a:solidFill>
@@ -3289,16 +3385,16 @@
           <a:cs typeface="+mn-cs"/>
         </a:defRPr>
       </a:lvl7pPr>
-      <a:lvl8pPr marL="738264" indent="-49218" algn="l" defTabSz="196870" rtl="0" eaLnBrk="1" latinLnBrk="0" hangingPunct="1">
+      <a:lvl8pPr marL="647738" indent="-43183" algn="l" defTabSz="172730" rtl="0" eaLnBrk="1" latinLnBrk="0" hangingPunct="1">
         <a:lnSpc>
           <a:spcPct val="90000"/>
         </a:lnSpc>
         <a:spcBef>
-          <a:spcPts val="108"/>
+          <a:spcPts val="94"/>
         </a:spcBef>
         <a:buFont typeface="Arial" panose="020B0604020202020204" pitchFamily="34" charset="0"/>
         <a:buChar char="•"/>
-        <a:defRPr sz="388" kern="1200">
+        <a:defRPr sz="340" kern="1200">
           <a:solidFill>
             <a:schemeClr val="tx1"/>
           </a:solidFill>
@@ -3307,16 +3403,16 @@
           <a:cs typeface="+mn-cs"/>
         </a:defRPr>
       </a:lvl8pPr>
-      <a:lvl9pPr marL="836699" indent="-49218" algn="l" defTabSz="196870" rtl="0" eaLnBrk="1" latinLnBrk="0" hangingPunct="1">
+      <a:lvl9pPr marL="734103" indent="-43183" algn="l" defTabSz="172730" rtl="0" eaLnBrk="1" latinLnBrk="0" hangingPunct="1">
         <a:lnSpc>
           <a:spcPct val="90000"/>
         </a:lnSpc>
         <a:spcBef>
-          <a:spcPts val="108"/>
+          <a:spcPts val="94"/>
         </a:spcBef>
         <a:buFont typeface="Arial" panose="020B0604020202020204" pitchFamily="34" charset="0"/>
         <a:buChar char="•"/>
-        <a:defRPr sz="388" kern="1200">
+        <a:defRPr sz="340" kern="1200">
           <a:solidFill>
             <a:schemeClr val="tx1"/>
           </a:solidFill>
@@ -3330,8 +3426,8 @@
       <a:defPPr>
         <a:defRPr lang="en-US"/>
       </a:defPPr>
-      <a:lvl1pPr marL="0" algn="l" defTabSz="196870" rtl="0" eaLnBrk="1" latinLnBrk="0" hangingPunct="1">
-        <a:defRPr sz="388" kern="1200">
+      <a:lvl1pPr marL="0" algn="l" defTabSz="172730" rtl="0" eaLnBrk="1" latinLnBrk="0" hangingPunct="1">
+        <a:defRPr sz="340" kern="1200">
           <a:solidFill>
             <a:schemeClr val="tx1"/>
           </a:solidFill>
@@ -3340,8 +3436,8 @@
           <a:cs typeface="+mn-cs"/>
         </a:defRPr>
       </a:lvl1pPr>
-      <a:lvl2pPr marL="98435" algn="l" defTabSz="196870" rtl="0" eaLnBrk="1" latinLnBrk="0" hangingPunct="1">
-        <a:defRPr sz="388" kern="1200">
+      <a:lvl2pPr marL="86365" algn="l" defTabSz="172730" rtl="0" eaLnBrk="1" latinLnBrk="0" hangingPunct="1">
+        <a:defRPr sz="340" kern="1200">
           <a:solidFill>
             <a:schemeClr val="tx1"/>
           </a:solidFill>
@@ -3350,8 +3446,8 @@
           <a:cs typeface="+mn-cs"/>
         </a:defRPr>
       </a:lvl2pPr>
-      <a:lvl3pPr marL="196870" algn="l" defTabSz="196870" rtl="0" eaLnBrk="1" latinLnBrk="0" hangingPunct="1">
-        <a:defRPr sz="388" kern="1200">
+      <a:lvl3pPr marL="172730" algn="l" defTabSz="172730" rtl="0" eaLnBrk="1" latinLnBrk="0" hangingPunct="1">
+        <a:defRPr sz="340" kern="1200">
           <a:solidFill>
             <a:schemeClr val="tx1"/>
           </a:solidFill>
@@ -3360,8 +3456,8 @@
           <a:cs typeface="+mn-cs"/>
         </a:defRPr>
       </a:lvl3pPr>
-      <a:lvl4pPr marL="295305" algn="l" defTabSz="196870" rtl="0" eaLnBrk="1" latinLnBrk="0" hangingPunct="1">
-        <a:defRPr sz="388" kern="1200">
+      <a:lvl4pPr marL="259095" algn="l" defTabSz="172730" rtl="0" eaLnBrk="1" latinLnBrk="0" hangingPunct="1">
+        <a:defRPr sz="340" kern="1200">
           <a:solidFill>
             <a:schemeClr val="tx1"/>
           </a:solidFill>
@@ -3370,8 +3466,8 @@
           <a:cs typeface="+mn-cs"/>
         </a:defRPr>
       </a:lvl4pPr>
-      <a:lvl5pPr marL="393741" algn="l" defTabSz="196870" rtl="0" eaLnBrk="1" latinLnBrk="0" hangingPunct="1">
-        <a:defRPr sz="388" kern="1200">
+      <a:lvl5pPr marL="345460" algn="l" defTabSz="172730" rtl="0" eaLnBrk="1" latinLnBrk="0" hangingPunct="1">
+        <a:defRPr sz="340" kern="1200">
           <a:solidFill>
             <a:schemeClr val="tx1"/>
           </a:solidFill>
@@ -3380,8 +3476,8 @@
           <a:cs typeface="+mn-cs"/>
         </a:defRPr>
       </a:lvl5pPr>
-      <a:lvl6pPr marL="492176" algn="l" defTabSz="196870" rtl="0" eaLnBrk="1" latinLnBrk="0" hangingPunct="1">
-        <a:defRPr sz="388" kern="1200">
+      <a:lvl6pPr marL="431825" algn="l" defTabSz="172730" rtl="0" eaLnBrk="1" latinLnBrk="0" hangingPunct="1">
+        <a:defRPr sz="340" kern="1200">
           <a:solidFill>
             <a:schemeClr val="tx1"/>
           </a:solidFill>
@@ -3390,8 +3486,8 @@
           <a:cs typeface="+mn-cs"/>
         </a:defRPr>
       </a:lvl6pPr>
-      <a:lvl7pPr marL="590611" algn="l" defTabSz="196870" rtl="0" eaLnBrk="1" latinLnBrk="0" hangingPunct="1">
-        <a:defRPr sz="388" kern="1200">
+      <a:lvl7pPr marL="518190" algn="l" defTabSz="172730" rtl="0" eaLnBrk="1" latinLnBrk="0" hangingPunct="1">
+        <a:defRPr sz="340" kern="1200">
           <a:solidFill>
             <a:schemeClr val="tx1"/>
           </a:solidFill>
@@ -3400,8 +3496,8 @@
           <a:cs typeface="+mn-cs"/>
         </a:defRPr>
       </a:lvl7pPr>
-      <a:lvl8pPr marL="689046" algn="l" defTabSz="196870" rtl="0" eaLnBrk="1" latinLnBrk="0" hangingPunct="1">
-        <a:defRPr sz="388" kern="1200">
+      <a:lvl8pPr marL="604556" algn="l" defTabSz="172730" rtl="0" eaLnBrk="1" latinLnBrk="0" hangingPunct="1">
+        <a:defRPr sz="340" kern="1200">
           <a:solidFill>
             <a:schemeClr val="tx1"/>
           </a:solidFill>
@@ -3410,8 +3506,8 @@
           <a:cs typeface="+mn-cs"/>
         </a:defRPr>
       </a:lvl8pPr>
-      <a:lvl9pPr marL="787481" algn="l" defTabSz="196870" rtl="0" eaLnBrk="1" latinLnBrk="0" hangingPunct="1">
-        <a:defRPr sz="388" kern="1200">
+      <a:lvl9pPr marL="690921" algn="l" defTabSz="172730" rtl="0" eaLnBrk="1" latinLnBrk="0" hangingPunct="1">
+        <a:defRPr sz="340" kern="1200">
           <a:solidFill>
             <a:schemeClr val="tx1"/>
           </a:solidFill>
@@ -3444,7 +3540,7 @@
       </p:grpSpPr>
       <p:sp>
         <p:nvSpPr>
-          <p:cNvPr id="3" name="TextBox 2">
+          <p:cNvPr id="57" name="TextBox 56">
             <a:extLst>
               <a:ext uri="{FF2B5EF4-FFF2-40B4-BE49-F238E27FC236}">
                 <a16:creationId xmlns:a16="http://schemas.microsoft.com/office/drawing/2014/main" id="{F4E1EB47-FB49-B221-8F40-6FAAC8188E34}"/>
@@ -3503,7 +3599,7 @@
       </p:sp>
       <p:sp>
         <p:nvSpPr>
-          <p:cNvPr id="4" name="TextBox 3">
+          <p:cNvPr id="58" name="TextBox 57">
             <a:extLst>
               <a:ext uri="{FF2B5EF4-FFF2-40B4-BE49-F238E27FC236}">
                 <a16:creationId xmlns:a16="http://schemas.microsoft.com/office/drawing/2014/main" id="{255FCF48-52E3-4492-E94D-63EC8B3349BF}"/>
@@ -3515,7 +3611,7 @@
         </p:nvSpPr>
         <p:spPr>
           <a:xfrm>
-            <a:off x="344831" y="1308971"/>
+            <a:off x="344831" y="1144168"/>
             <a:ext cx="433132" cy="215444"/>
           </a:xfrm>
           <a:prstGeom prst="rect">
@@ -3547,7 +3643,7 @@
       </p:sp>
       <p:sp>
         <p:nvSpPr>
-          <p:cNvPr id="5" name="TextBox 4">
+          <p:cNvPr id="59" name="TextBox 58">
             <a:extLst>
               <a:ext uri="{FF2B5EF4-FFF2-40B4-BE49-F238E27FC236}">
                 <a16:creationId xmlns:a16="http://schemas.microsoft.com/office/drawing/2014/main" id="{8DD953F0-D574-7288-6232-DB349985D1C7}"/>
@@ -3559,7 +3655,7 @@
         </p:nvSpPr>
         <p:spPr>
           <a:xfrm rot="16200000">
-            <a:off x="-290639" y="862506"/>
+            <a:off x="-290639" y="697703"/>
             <a:ext cx="678565" cy="215444"/>
           </a:xfrm>
           <a:prstGeom prst="rect">
@@ -3592,7 +3688,7 @@
       </p:sp>
       <p:sp>
         <p:nvSpPr>
-          <p:cNvPr id="6" name="Rectangle 5">
+          <p:cNvPr id="60" name="Rectangle 59">
             <a:extLst>
               <a:ext uri="{FF2B5EF4-FFF2-40B4-BE49-F238E27FC236}">
                 <a16:creationId xmlns:a16="http://schemas.microsoft.com/office/drawing/2014/main" id="{0770A906-9CF0-0CA7-E0F3-6CE28EFD5D88}"/>
@@ -3604,7 +3700,7 @@
         </p:nvSpPr>
         <p:spPr>
           <a:xfrm>
-            <a:off x="293327" y="700228"/>
+            <a:off x="293327" y="535425"/>
             <a:ext cx="540000" cy="540000"/>
           </a:xfrm>
           <a:prstGeom prst="rect">
@@ -3656,7 +3752,7 @@
       </p:sp>
       <p:sp>
         <p:nvSpPr>
-          <p:cNvPr id="7" name="TextBox 6">
+          <p:cNvPr id="61" name="TextBox 60">
             <a:extLst>
               <a:ext uri="{FF2B5EF4-FFF2-40B4-BE49-F238E27FC236}">
                 <a16:creationId xmlns:a16="http://schemas.microsoft.com/office/drawing/2014/main" id="{F86498FD-11B7-6E9F-93AC-A2EA1AAF283D}"/>
@@ -3668,7 +3764,7 @@
         </p:nvSpPr>
         <p:spPr>
           <a:xfrm>
-            <a:off x="417593" y="1193170"/>
+            <a:off x="417593" y="1028367"/>
             <a:ext cx="312906" cy="215444"/>
           </a:xfrm>
           <a:prstGeom prst="rect">
@@ -3700,7 +3796,7 @@
       </p:sp>
       <p:sp>
         <p:nvSpPr>
-          <p:cNvPr id="8" name="TextBox 7">
+          <p:cNvPr id="62" name="TextBox 61">
             <a:extLst>
               <a:ext uri="{FF2B5EF4-FFF2-40B4-BE49-F238E27FC236}">
                 <a16:creationId xmlns:a16="http://schemas.microsoft.com/office/drawing/2014/main" id="{32FBFAAE-FDB5-9C28-E4FB-9767C60AD9AD}"/>
@@ -3712,7 +3808,7 @@
         </p:nvSpPr>
         <p:spPr>
           <a:xfrm>
-            <a:off x="186399" y="1193170"/>
+            <a:off x="186399" y="1028367"/>
             <a:ext cx="243978" cy="215444"/>
           </a:xfrm>
           <a:prstGeom prst="rect">
@@ -3744,7 +3840,7 @@
       </p:sp>
       <p:sp>
         <p:nvSpPr>
-          <p:cNvPr id="9" name="TextBox 8">
+          <p:cNvPr id="63" name="TextBox 62">
             <a:extLst>
               <a:ext uri="{FF2B5EF4-FFF2-40B4-BE49-F238E27FC236}">
                 <a16:creationId xmlns:a16="http://schemas.microsoft.com/office/drawing/2014/main" id="{1245B2E3-697E-EF7F-6DE7-398837E648D8}"/>
@@ -3756,7 +3852,7 @@
         </p:nvSpPr>
         <p:spPr>
           <a:xfrm>
-            <a:off x="717715" y="1193170"/>
+            <a:off x="717715" y="1028367"/>
             <a:ext cx="243978" cy="215444"/>
           </a:xfrm>
           <a:prstGeom prst="rect">
@@ -3788,7 +3884,7 @@
       </p:sp>
       <p:cxnSp>
         <p:nvCxnSpPr>
-          <p:cNvPr id="10" name="Straight Connector 9">
+          <p:cNvPr id="64" name="Straight Connector 63">
             <a:extLst>
               <a:ext uri="{FF2B5EF4-FFF2-40B4-BE49-F238E27FC236}">
                 <a16:creationId xmlns:a16="http://schemas.microsoft.com/office/drawing/2014/main" id="{F6AE0A53-5537-0BEB-0D7E-587C0BED06FB}"/>
@@ -3802,7 +3898,7 @@
         </p:nvCxnSpPr>
         <p:spPr>
           <a:xfrm rot="5400000" flipV="1">
-            <a:off x="290454" y="703542"/>
+            <a:off x="290454" y="538739"/>
             <a:ext cx="539404" cy="539308"/>
           </a:xfrm>
           <a:prstGeom prst="line">
@@ -3834,7 +3930,7 @@
       </p:cxnSp>
       <p:sp>
         <p:nvSpPr>
-          <p:cNvPr id="11" name="TextBox 10">
+          <p:cNvPr id="65" name="TextBox 64">
             <a:extLst>
               <a:ext uri="{FF2B5EF4-FFF2-40B4-BE49-F238E27FC236}">
                 <a16:creationId xmlns:a16="http://schemas.microsoft.com/office/drawing/2014/main" id="{C9F997BA-C09E-F977-2962-97E5EC2E4278}"/>
@@ -3846,7 +3942,7 @@
         </p:nvSpPr>
         <p:spPr>
           <a:xfrm>
-            <a:off x="118559" y="1122856"/>
+            <a:off x="118559" y="958053"/>
             <a:ext cx="243978" cy="215444"/>
           </a:xfrm>
           <a:prstGeom prst="rect">
@@ -3879,7 +3975,7 @@
       </p:sp>
       <p:sp>
         <p:nvSpPr>
-          <p:cNvPr id="12" name="TextBox 11">
+          <p:cNvPr id="66" name="TextBox 65">
             <a:extLst>
               <a:ext uri="{FF2B5EF4-FFF2-40B4-BE49-F238E27FC236}">
                 <a16:creationId xmlns:a16="http://schemas.microsoft.com/office/drawing/2014/main" id="{FB02B0F6-DBE2-75A9-BE9E-2017ED295806}"/>
@@ -3891,7 +3987,7 @@
         </p:nvSpPr>
         <p:spPr>
           <a:xfrm>
-            <a:off x="118559" y="595306"/>
+            <a:off x="118559" y="430503"/>
             <a:ext cx="243978" cy="215444"/>
           </a:xfrm>
           <a:prstGeom prst="rect">
@@ -3924,7 +4020,7 @@
       </p:sp>
       <p:sp>
         <p:nvSpPr>
-          <p:cNvPr id="13" name="TextBox 12">
+          <p:cNvPr id="67" name="TextBox 66">
             <a:extLst>
               <a:ext uri="{FF2B5EF4-FFF2-40B4-BE49-F238E27FC236}">
                 <a16:creationId xmlns:a16="http://schemas.microsoft.com/office/drawing/2014/main" id="{5CA2A36E-AB3C-E4C2-E36B-5896CE1876A3}"/>
@@ -3936,7 +4032,7 @@
         </p:nvSpPr>
         <p:spPr>
           <a:xfrm>
-            <a:off x="49631" y="859081"/>
+            <a:off x="49631" y="694278"/>
             <a:ext cx="312906" cy="215444"/>
           </a:xfrm>
           <a:prstGeom prst="rect">
@@ -3969,7 +4065,7 @@
       </p:sp>
       <p:sp>
         <p:nvSpPr>
-          <p:cNvPr id="14" name="TextBox 13">
+          <p:cNvPr id="68" name="TextBox 67">
             <a:extLst>
               <a:ext uri="{FF2B5EF4-FFF2-40B4-BE49-F238E27FC236}">
                 <a16:creationId xmlns:a16="http://schemas.microsoft.com/office/drawing/2014/main" id="{4BE5230C-F284-DA67-6488-204B230E83EC}"/>
@@ -3981,7 +4077,7 @@
         </p:nvSpPr>
         <p:spPr>
           <a:xfrm>
-            <a:off x="289743" y="497704"/>
+            <a:off x="289743" y="332901"/>
             <a:ext cx="540000" cy="215444"/>
           </a:xfrm>
           <a:prstGeom prst="rect">
@@ -4014,7 +4110,7 @@
       </p:sp>
       <p:sp>
         <p:nvSpPr>
-          <p:cNvPr id="15" name="TextBox 14">
+          <p:cNvPr id="69" name="TextBox 68">
             <a:extLst>
               <a:ext uri="{FF2B5EF4-FFF2-40B4-BE49-F238E27FC236}">
                 <a16:creationId xmlns:a16="http://schemas.microsoft.com/office/drawing/2014/main" id="{C17130AE-9C84-70A6-B5E3-D8C639C2F071}"/>
@@ -4026,7 +4122,7 @@
         </p:nvSpPr>
         <p:spPr>
           <a:xfrm>
-            <a:off x="1401586" y="1315107"/>
+            <a:off x="1401586" y="1150304"/>
             <a:ext cx="433132" cy="215444"/>
           </a:xfrm>
           <a:prstGeom prst="rect">
@@ -4058,7 +4154,7 @@
       </p:sp>
       <p:sp>
         <p:nvSpPr>
-          <p:cNvPr id="16" name="Rectangle 15">
+          <p:cNvPr id="70" name="Rectangle 69">
             <a:extLst>
               <a:ext uri="{FF2B5EF4-FFF2-40B4-BE49-F238E27FC236}">
                 <a16:creationId xmlns:a16="http://schemas.microsoft.com/office/drawing/2014/main" id="{B2A59DDD-285A-7034-B1F5-70C3236EEB8E}"/>
@@ -4070,7 +4166,7 @@
         </p:nvSpPr>
         <p:spPr>
           <a:xfrm>
-            <a:off x="1347882" y="700228"/>
+            <a:off x="1347882" y="535425"/>
             <a:ext cx="540000" cy="540000"/>
           </a:xfrm>
           <a:prstGeom prst="rect">
@@ -4122,7 +4218,7 @@
       </p:sp>
       <p:sp>
         <p:nvSpPr>
-          <p:cNvPr id="17" name="TextBox 16">
+          <p:cNvPr id="71" name="TextBox 70">
             <a:extLst>
               <a:ext uri="{FF2B5EF4-FFF2-40B4-BE49-F238E27FC236}">
                 <a16:creationId xmlns:a16="http://schemas.microsoft.com/office/drawing/2014/main" id="{4FD4C487-6A2F-D1A5-8C60-2E89034A0BCF}"/>
@@ -4134,7 +4230,7 @@
         </p:nvSpPr>
         <p:spPr>
           <a:xfrm>
-            <a:off x="1472148" y="1193170"/>
+            <a:off x="1472148" y="1028367"/>
             <a:ext cx="312906" cy="215444"/>
           </a:xfrm>
           <a:prstGeom prst="rect">
@@ -4166,7 +4262,7 @@
       </p:sp>
       <p:sp>
         <p:nvSpPr>
-          <p:cNvPr id="18" name="TextBox 17">
+          <p:cNvPr id="72" name="TextBox 71">
             <a:extLst>
               <a:ext uri="{FF2B5EF4-FFF2-40B4-BE49-F238E27FC236}">
                 <a16:creationId xmlns:a16="http://schemas.microsoft.com/office/drawing/2014/main" id="{C7497309-3825-8F73-491C-1F065C389560}"/>
@@ -4178,7 +4274,7 @@
         </p:nvSpPr>
         <p:spPr>
           <a:xfrm>
-            <a:off x="1240954" y="1193170"/>
+            <a:off x="1240954" y="1028367"/>
             <a:ext cx="243978" cy="215444"/>
           </a:xfrm>
           <a:prstGeom prst="rect">
@@ -4210,7 +4306,7 @@
       </p:sp>
       <p:sp>
         <p:nvSpPr>
-          <p:cNvPr id="19" name="TextBox 18">
+          <p:cNvPr id="73" name="TextBox 72">
             <a:extLst>
               <a:ext uri="{FF2B5EF4-FFF2-40B4-BE49-F238E27FC236}">
                 <a16:creationId xmlns:a16="http://schemas.microsoft.com/office/drawing/2014/main" id="{0B7447C1-71A7-53DA-FA4A-60695C6142B4}"/>
@@ -4222,7 +4318,7 @@
         </p:nvSpPr>
         <p:spPr>
           <a:xfrm>
-            <a:off x="1772270" y="1193170"/>
+            <a:off x="1772270" y="1028367"/>
             <a:ext cx="243978" cy="215444"/>
           </a:xfrm>
           <a:prstGeom prst="rect">
@@ -4254,7 +4350,7 @@
       </p:sp>
       <p:cxnSp>
         <p:nvCxnSpPr>
-          <p:cNvPr id="20" name="Straight Connector 19">
+          <p:cNvPr id="74" name="Straight Connector 73">
             <a:extLst>
               <a:ext uri="{FF2B5EF4-FFF2-40B4-BE49-F238E27FC236}">
                 <a16:creationId xmlns:a16="http://schemas.microsoft.com/office/drawing/2014/main" id="{82598C5A-D9D6-C729-4217-96ADE0D324AF}"/>
@@ -4268,7 +4364,7 @@
         </p:nvCxnSpPr>
         <p:spPr>
           <a:xfrm rot="5400000" flipV="1">
-            <a:off x="1348639" y="703542"/>
+            <a:off x="1348639" y="538739"/>
             <a:ext cx="539404" cy="539308"/>
           </a:xfrm>
           <a:prstGeom prst="line">
@@ -4300,7 +4396,7 @@
       </p:cxnSp>
       <p:sp>
         <p:nvSpPr>
-          <p:cNvPr id="21" name="TextBox 20">
+          <p:cNvPr id="75" name="TextBox 74">
             <a:extLst>
               <a:ext uri="{FF2B5EF4-FFF2-40B4-BE49-F238E27FC236}">
                 <a16:creationId xmlns:a16="http://schemas.microsoft.com/office/drawing/2014/main" id="{4B572820-B33D-97E7-3F9A-1E53270FD862}"/>
@@ -4312,7 +4408,7 @@
         </p:nvSpPr>
         <p:spPr>
           <a:xfrm>
-            <a:off x="1173114" y="1122856"/>
+            <a:off x="1173114" y="958053"/>
             <a:ext cx="243978" cy="215444"/>
           </a:xfrm>
           <a:prstGeom prst="rect">
@@ -4345,7 +4441,7 @@
       </p:sp>
       <p:sp>
         <p:nvSpPr>
-          <p:cNvPr id="22" name="TextBox 21">
+          <p:cNvPr id="76" name="TextBox 75">
             <a:extLst>
               <a:ext uri="{FF2B5EF4-FFF2-40B4-BE49-F238E27FC236}">
                 <a16:creationId xmlns:a16="http://schemas.microsoft.com/office/drawing/2014/main" id="{0559E9B8-ED2A-B7C5-CD99-FCCACB55B247}"/>
@@ -4357,7 +4453,7 @@
         </p:nvSpPr>
         <p:spPr>
           <a:xfrm>
-            <a:off x="1173114" y="595306"/>
+            <a:off x="1173114" y="430503"/>
             <a:ext cx="243978" cy="215444"/>
           </a:xfrm>
           <a:prstGeom prst="rect">
@@ -4390,7 +4486,7 @@
       </p:sp>
       <p:sp>
         <p:nvSpPr>
-          <p:cNvPr id="23" name="TextBox 22">
+          <p:cNvPr id="77" name="TextBox 76">
             <a:extLst>
               <a:ext uri="{FF2B5EF4-FFF2-40B4-BE49-F238E27FC236}">
                 <a16:creationId xmlns:a16="http://schemas.microsoft.com/office/drawing/2014/main" id="{3E9A054A-1E9C-43D8-1A4D-7AC5D9228D29}"/>
@@ -4402,7 +4498,7 @@
         </p:nvSpPr>
         <p:spPr>
           <a:xfrm>
-            <a:off x="1104186" y="859081"/>
+            <a:off x="1104186" y="694278"/>
             <a:ext cx="312906" cy="215444"/>
           </a:xfrm>
           <a:prstGeom prst="rect">
@@ -4435,7 +4531,7 @@
       </p:sp>
       <p:sp>
         <p:nvSpPr>
-          <p:cNvPr id="24" name="TextBox 23">
+          <p:cNvPr id="78" name="TextBox 77">
             <a:extLst>
               <a:ext uri="{FF2B5EF4-FFF2-40B4-BE49-F238E27FC236}">
                 <a16:creationId xmlns:a16="http://schemas.microsoft.com/office/drawing/2014/main" id="{00472CBD-CB17-A7EF-5FDC-A2F6815385EA}"/>
@@ -4447,7 +4543,7 @@
         </p:nvSpPr>
         <p:spPr>
           <a:xfrm>
-            <a:off x="1344298" y="497704"/>
+            <a:off x="1344298" y="332901"/>
             <a:ext cx="540000" cy="215444"/>
           </a:xfrm>
           <a:prstGeom prst="rect">
@@ -4480,7 +4576,7 @@
       </p:sp>
       <p:sp>
         <p:nvSpPr>
-          <p:cNvPr id="25" name="TextBox 24">
+          <p:cNvPr id="79" name="TextBox 78">
             <a:extLst>
               <a:ext uri="{FF2B5EF4-FFF2-40B4-BE49-F238E27FC236}">
                 <a16:creationId xmlns:a16="http://schemas.microsoft.com/office/drawing/2014/main" id="{06FE1007-0DAE-599E-2214-69669DEB30C2}"/>
@@ -4492,7 +4588,7 @@
         </p:nvSpPr>
         <p:spPr>
           <a:xfrm>
-            <a:off x="2448271" y="1306310"/>
+            <a:off x="2448271" y="1141507"/>
             <a:ext cx="433132" cy="215444"/>
           </a:xfrm>
           <a:prstGeom prst="rect">
@@ -4524,7 +4620,7 @@
       </p:sp>
       <p:sp>
         <p:nvSpPr>
-          <p:cNvPr id="26" name="Rectangle 25">
+          <p:cNvPr id="80" name="Rectangle 79">
             <a:extLst>
               <a:ext uri="{FF2B5EF4-FFF2-40B4-BE49-F238E27FC236}">
                 <a16:creationId xmlns:a16="http://schemas.microsoft.com/office/drawing/2014/main" id="{6D8A9C3F-217E-9DEA-31D3-F668D73532C6}"/>
@@ -4536,7 +4632,7 @@
         </p:nvSpPr>
         <p:spPr>
           <a:xfrm>
-            <a:off x="2402437" y="700228"/>
+            <a:off x="2402437" y="535425"/>
             <a:ext cx="540000" cy="540000"/>
           </a:xfrm>
           <a:prstGeom prst="rect">
@@ -4588,7 +4684,7 @@
       </p:sp>
       <p:sp>
         <p:nvSpPr>
-          <p:cNvPr id="27" name="TextBox 26">
+          <p:cNvPr id="81" name="TextBox 80">
             <a:extLst>
               <a:ext uri="{FF2B5EF4-FFF2-40B4-BE49-F238E27FC236}">
                 <a16:creationId xmlns:a16="http://schemas.microsoft.com/office/drawing/2014/main" id="{DC726D64-1E53-9623-8AEB-CDFEBC54B3A2}"/>
@@ -4600,7 +4696,7 @@
         </p:nvSpPr>
         <p:spPr>
           <a:xfrm>
-            <a:off x="2526703" y="1193170"/>
+            <a:off x="2526703" y="1028367"/>
             <a:ext cx="312906" cy="215444"/>
           </a:xfrm>
           <a:prstGeom prst="rect">
@@ -4632,7 +4728,7 @@
       </p:sp>
       <p:sp>
         <p:nvSpPr>
-          <p:cNvPr id="28" name="TextBox 27">
+          <p:cNvPr id="82" name="TextBox 81">
             <a:extLst>
               <a:ext uri="{FF2B5EF4-FFF2-40B4-BE49-F238E27FC236}">
                 <a16:creationId xmlns:a16="http://schemas.microsoft.com/office/drawing/2014/main" id="{0CF803A3-4BEB-9400-7B38-57E687183C6D}"/>
@@ -4644,7 +4740,7 @@
         </p:nvSpPr>
         <p:spPr>
           <a:xfrm>
-            <a:off x="2295509" y="1193170"/>
+            <a:off x="2295509" y="1028367"/>
             <a:ext cx="243978" cy="215444"/>
           </a:xfrm>
           <a:prstGeom prst="rect">
@@ -4676,7 +4772,7 @@
       </p:sp>
       <p:sp>
         <p:nvSpPr>
-          <p:cNvPr id="29" name="TextBox 28">
+          <p:cNvPr id="83" name="TextBox 82">
             <a:extLst>
               <a:ext uri="{FF2B5EF4-FFF2-40B4-BE49-F238E27FC236}">
                 <a16:creationId xmlns:a16="http://schemas.microsoft.com/office/drawing/2014/main" id="{B9FD6C18-DBDE-1EE4-FADB-2B22F8257AA8}"/>
@@ -4688,7 +4784,7 @@
         </p:nvSpPr>
         <p:spPr>
           <a:xfrm>
-            <a:off x="2826825" y="1193170"/>
+            <a:off x="2826825" y="1028367"/>
             <a:ext cx="243978" cy="215444"/>
           </a:xfrm>
           <a:prstGeom prst="rect">
@@ -4720,7 +4816,7 @@
       </p:sp>
       <p:cxnSp>
         <p:nvCxnSpPr>
-          <p:cNvPr id="30" name="Straight Connector 29">
+          <p:cNvPr id="84" name="Straight Connector 83">
             <a:extLst>
               <a:ext uri="{FF2B5EF4-FFF2-40B4-BE49-F238E27FC236}">
                 <a16:creationId xmlns:a16="http://schemas.microsoft.com/office/drawing/2014/main" id="{65EA298F-0D64-5654-88B6-2A2F7068B6E6}"/>
@@ -4734,7 +4830,7 @@
         </p:nvCxnSpPr>
         <p:spPr>
           <a:xfrm rot="5400000" flipV="1">
-            <a:off x="2407166" y="704140"/>
+            <a:off x="2407166" y="539337"/>
             <a:ext cx="539404" cy="539308"/>
           </a:xfrm>
           <a:prstGeom prst="line">
@@ -4766,7 +4862,7 @@
       </p:cxnSp>
       <p:sp>
         <p:nvSpPr>
-          <p:cNvPr id="31" name="TextBox 30">
+          <p:cNvPr id="85" name="TextBox 84">
             <a:extLst>
               <a:ext uri="{FF2B5EF4-FFF2-40B4-BE49-F238E27FC236}">
                 <a16:creationId xmlns:a16="http://schemas.microsoft.com/office/drawing/2014/main" id="{3A123093-7B31-331E-36C8-0D76F6297454}"/>
@@ -4778,7 +4874,7 @@
         </p:nvSpPr>
         <p:spPr>
           <a:xfrm>
-            <a:off x="2227669" y="1122856"/>
+            <a:off x="2227669" y="958053"/>
             <a:ext cx="243978" cy="215444"/>
           </a:xfrm>
           <a:prstGeom prst="rect">
@@ -4811,7 +4907,7 @@
       </p:sp>
       <p:sp>
         <p:nvSpPr>
-          <p:cNvPr id="32" name="TextBox 31">
+          <p:cNvPr id="86" name="TextBox 85">
             <a:extLst>
               <a:ext uri="{FF2B5EF4-FFF2-40B4-BE49-F238E27FC236}">
                 <a16:creationId xmlns:a16="http://schemas.microsoft.com/office/drawing/2014/main" id="{AEF79955-9585-5CF1-C444-DDF210469501}"/>
@@ -4823,7 +4919,7 @@
         </p:nvSpPr>
         <p:spPr>
           <a:xfrm>
-            <a:off x="2227669" y="595306"/>
+            <a:off x="2227669" y="430503"/>
             <a:ext cx="243978" cy="215444"/>
           </a:xfrm>
           <a:prstGeom prst="rect">
@@ -4856,7 +4952,7 @@
       </p:sp>
       <p:sp>
         <p:nvSpPr>
-          <p:cNvPr id="33" name="TextBox 32">
+          <p:cNvPr id="87" name="TextBox 86">
             <a:extLst>
               <a:ext uri="{FF2B5EF4-FFF2-40B4-BE49-F238E27FC236}">
                 <a16:creationId xmlns:a16="http://schemas.microsoft.com/office/drawing/2014/main" id="{8ACFC326-BACC-6902-14F7-BFEEE6666E1E}"/>
@@ -4868,7 +4964,7 @@
         </p:nvSpPr>
         <p:spPr>
           <a:xfrm>
-            <a:off x="2158741" y="859081"/>
+            <a:off x="2158741" y="694278"/>
             <a:ext cx="312906" cy="215444"/>
           </a:xfrm>
           <a:prstGeom prst="rect">
@@ -4901,7 +4997,7 @@
       </p:sp>
       <p:sp>
         <p:nvSpPr>
-          <p:cNvPr id="34" name="TextBox 33">
+          <p:cNvPr id="88" name="TextBox 87">
             <a:extLst>
               <a:ext uri="{FF2B5EF4-FFF2-40B4-BE49-F238E27FC236}">
                 <a16:creationId xmlns:a16="http://schemas.microsoft.com/office/drawing/2014/main" id="{05F40DB0-4698-E06C-0A8E-89913B152B5D}"/>
@@ -4913,7 +5009,7 @@
         </p:nvSpPr>
         <p:spPr>
           <a:xfrm>
-            <a:off x="2398853" y="497704"/>
+            <a:off x="2398853" y="332901"/>
             <a:ext cx="540000" cy="215444"/>
           </a:xfrm>
           <a:prstGeom prst="rect">
@@ -4946,7 +5042,7 @@
       </p:sp>
       <p:sp>
         <p:nvSpPr>
-          <p:cNvPr id="35" name="TextBox 34">
+          <p:cNvPr id="89" name="TextBox 88">
             <a:extLst>
               <a:ext uri="{FF2B5EF4-FFF2-40B4-BE49-F238E27FC236}">
                 <a16:creationId xmlns:a16="http://schemas.microsoft.com/office/drawing/2014/main" id="{1522668D-8253-2DF2-841F-181CA4892F52}"/>
@@ -4958,7 +5054,7 @@
         </p:nvSpPr>
         <p:spPr>
           <a:xfrm>
-            <a:off x="3505892" y="1307851"/>
+            <a:off x="3505892" y="1143048"/>
             <a:ext cx="433132" cy="215444"/>
           </a:xfrm>
           <a:prstGeom prst="rect">
@@ -4990,7 +5086,7 @@
       </p:sp>
       <p:sp>
         <p:nvSpPr>
-          <p:cNvPr id="36" name="Rectangle 35">
+          <p:cNvPr id="90" name="Rectangle 89">
             <a:extLst>
               <a:ext uri="{FF2B5EF4-FFF2-40B4-BE49-F238E27FC236}">
                 <a16:creationId xmlns:a16="http://schemas.microsoft.com/office/drawing/2014/main" id="{0DA10788-F022-5F4F-7E6A-BC6318793D52}"/>
@@ -5002,7 +5098,7 @@
         </p:nvSpPr>
         <p:spPr>
           <a:xfrm>
-            <a:off x="3456992" y="700228"/>
+            <a:off x="3456992" y="535425"/>
             <a:ext cx="540000" cy="540000"/>
           </a:xfrm>
           <a:prstGeom prst="rect">
@@ -5054,7 +5150,7 @@
       </p:sp>
       <p:sp>
         <p:nvSpPr>
-          <p:cNvPr id="37" name="TextBox 36">
+          <p:cNvPr id="91" name="TextBox 90">
             <a:extLst>
               <a:ext uri="{FF2B5EF4-FFF2-40B4-BE49-F238E27FC236}">
                 <a16:creationId xmlns:a16="http://schemas.microsoft.com/office/drawing/2014/main" id="{0F9E7280-5D40-9558-A401-287F029CE5A4}"/>
@@ -5066,7 +5162,7 @@
         </p:nvSpPr>
         <p:spPr>
           <a:xfrm>
-            <a:off x="3581258" y="1193170"/>
+            <a:off x="3581258" y="1028367"/>
             <a:ext cx="312906" cy="215444"/>
           </a:xfrm>
           <a:prstGeom prst="rect">
@@ -5098,7 +5194,7 @@
       </p:sp>
       <p:sp>
         <p:nvSpPr>
-          <p:cNvPr id="38" name="TextBox 37">
+          <p:cNvPr id="92" name="TextBox 91">
             <a:extLst>
               <a:ext uri="{FF2B5EF4-FFF2-40B4-BE49-F238E27FC236}">
                 <a16:creationId xmlns:a16="http://schemas.microsoft.com/office/drawing/2014/main" id="{3F9004C2-032E-AE52-1A5E-5FEED9C5F2DC}"/>
@@ -5110,7 +5206,7 @@
         </p:nvSpPr>
         <p:spPr>
           <a:xfrm>
-            <a:off x="3350064" y="1193170"/>
+            <a:off x="3350064" y="1028367"/>
             <a:ext cx="243978" cy="215444"/>
           </a:xfrm>
           <a:prstGeom prst="rect">
@@ -5142,7 +5238,7 @@
       </p:sp>
       <p:sp>
         <p:nvSpPr>
-          <p:cNvPr id="39" name="TextBox 38">
+          <p:cNvPr id="93" name="TextBox 92">
             <a:extLst>
               <a:ext uri="{FF2B5EF4-FFF2-40B4-BE49-F238E27FC236}">
                 <a16:creationId xmlns:a16="http://schemas.microsoft.com/office/drawing/2014/main" id="{B2394BC8-687D-D688-2D19-7127147A70A1}"/>
@@ -5154,7 +5250,7 @@
         </p:nvSpPr>
         <p:spPr>
           <a:xfrm>
-            <a:off x="3881380" y="1193170"/>
+            <a:off x="3881380" y="1028367"/>
             <a:ext cx="243978" cy="215444"/>
           </a:xfrm>
           <a:prstGeom prst="rect">
@@ -5186,7 +5282,7 @@
       </p:sp>
       <p:cxnSp>
         <p:nvCxnSpPr>
-          <p:cNvPr id="40" name="Straight Connector 39">
+          <p:cNvPr id="94" name="Straight Connector 93">
             <a:extLst>
               <a:ext uri="{FF2B5EF4-FFF2-40B4-BE49-F238E27FC236}">
                 <a16:creationId xmlns:a16="http://schemas.microsoft.com/office/drawing/2014/main" id="{3FF89A01-C26A-9C57-05E8-1FB4A07BE5F9}"/>
@@ -5200,7 +5296,7 @@
         </p:nvCxnSpPr>
         <p:spPr>
           <a:xfrm rot="16200000" flipV="1">
-            <a:off x="3463871" y="703542"/>
+            <a:off x="3463871" y="538739"/>
             <a:ext cx="539404" cy="539308"/>
           </a:xfrm>
           <a:prstGeom prst="line">
@@ -5232,7 +5328,7 @@
       </p:cxnSp>
       <p:sp>
         <p:nvSpPr>
-          <p:cNvPr id="41" name="TextBox 40">
+          <p:cNvPr id="95" name="TextBox 94">
             <a:extLst>
               <a:ext uri="{FF2B5EF4-FFF2-40B4-BE49-F238E27FC236}">
                 <a16:creationId xmlns:a16="http://schemas.microsoft.com/office/drawing/2014/main" id="{3E1A0180-88A4-FC9F-9519-D1D7BDCA0811}"/>
@@ -5244,7 +5340,7 @@
         </p:nvSpPr>
         <p:spPr>
           <a:xfrm>
-            <a:off x="3282224" y="1122856"/>
+            <a:off x="3282224" y="958053"/>
             <a:ext cx="243978" cy="215444"/>
           </a:xfrm>
           <a:prstGeom prst="rect">
@@ -5277,7 +5373,7 @@
       </p:sp>
       <p:sp>
         <p:nvSpPr>
-          <p:cNvPr id="42" name="TextBox 41">
+          <p:cNvPr id="96" name="TextBox 95">
             <a:extLst>
               <a:ext uri="{FF2B5EF4-FFF2-40B4-BE49-F238E27FC236}">
                 <a16:creationId xmlns:a16="http://schemas.microsoft.com/office/drawing/2014/main" id="{59FE1138-74BE-8717-2261-54DC19AC021C}"/>
@@ -5289,7 +5385,7 @@
         </p:nvSpPr>
         <p:spPr>
           <a:xfrm>
-            <a:off x="3282224" y="595306"/>
+            <a:off x="3282224" y="430503"/>
             <a:ext cx="243978" cy="215444"/>
           </a:xfrm>
           <a:prstGeom prst="rect">
@@ -5322,7 +5418,7 @@
       </p:sp>
       <p:sp>
         <p:nvSpPr>
-          <p:cNvPr id="43" name="TextBox 42">
+          <p:cNvPr id="97" name="TextBox 96">
             <a:extLst>
               <a:ext uri="{FF2B5EF4-FFF2-40B4-BE49-F238E27FC236}">
                 <a16:creationId xmlns:a16="http://schemas.microsoft.com/office/drawing/2014/main" id="{6294855B-E047-F82E-4381-14F2D4005F14}"/>
@@ -5334,7 +5430,7 @@
         </p:nvSpPr>
         <p:spPr>
           <a:xfrm>
-            <a:off x="3213296" y="859081"/>
+            <a:off x="3213296" y="694278"/>
             <a:ext cx="312906" cy="215444"/>
           </a:xfrm>
           <a:prstGeom prst="rect">
@@ -5367,7 +5463,7 @@
       </p:sp>
       <p:sp>
         <p:nvSpPr>
-          <p:cNvPr id="44" name="TextBox 43">
+          <p:cNvPr id="98" name="TextBox 97">
             <a:extLst>
               <a:ext uri="{FF2B5EF4-FFF2-40B4-BE49-F238E27FC236}">
                 <a16:creationId xmlns:a16="http://schemas.microsoft.com/office/drawing/2014/main" id="{96350757-4EAD-7E70-7E51-6A44C861C034}"/>
@@ -5379,7 +5475,7 @@
         </p:nvSpPr>
         <p:spPr>
           <a:xfrm>
-            <a:off x="3142551" y="485524"/>
+            <a:off x="3142551" y="332901"/>
             <a:ext cx="1112900" cy="215444"/>
           </a:xfrm>
           <a:prstGeom prst="rect">
@@ -5410,56 +5506,9 @@
           </a:p>
         </p:txBody>
       </p:sp>
-      <p:sp>
-        <p:nvSpPr>
-          <p:cNvPr id="45" name="TextBox 44">
-            <a:extLst>
-              <a:ext uri="{FF2B5EF4-FFF2-40B4-BE49-F238E27FC236}">
-                <a16:creationId xmlns:a16="http://schemas.microsoft.com/office/drawing/2014/main" id="{7439BC8B-CAC0-9D56-378A-90AA4CF80489}"/>
-              </a:ext>
-            </a:extLst>
-          </p:cNvPr>
-          <p:cNvSpPr txBox="1"/>
-          <p:nvPr/>
-        </p:nvSpPr>
-        <p:spPr>
-          <a:xfrm>
-            <a:off x="-76874" y="340509"/>
-            <a:ext cx="4217074" cy="215444"/>
-          </a:xfrm>
-          <a:prstGeom prst="rect">
-            <a:avLst/>
-          </a:prstGeom>
-          <a:noFill/>
-          <a:ln>
-            <a:noFill/>
-          </a:ln>
-        </p:spPr>
-        <p:txBody>
-          <a:bodyPr wrap="square" rtlCol="0">
-            <a:spAutoFit/>
-          </a:bodyPr>
-          <a:lstStyle/>
-          <a:p>
-            <a:r>
-              <a:rPr lang="en-US" sz="800" dirty="0">
-                <a:solidFill>
-                  <a:schemeClr val="tx1">
-                    <a:lumMod val="85000"/>
-                    <a:lumOff val="15000"/>
-                  </a:schemeClr>
-                </a:solidFill>
-                <a:latin typeface="Calibri Light" panose="020F0302020204030204" pitchFamily="34" charset="0"/>
-                <a:cs typeface="Calibri Light" panose="020F0302020204030204" pitchFamily="34" charset="0"/>
-              </a:rPr>
-              <a:t>a) Discrimination ability for imbalanced training datasets: precision-recall curves</a:t>
-            </a:r>
-          </a:p>
-        </p:txBody>
-      </p:sp>
       <p:cxnSp>
         <p:nvCxnSpPr>
-          <p:cNvPr id="46" name="Straight Connector 45">
+          <p:cNvPr id="99" name="Straight Connector 98">
             <a:extLst>
               <a:ext uri="{FF2B5EF4-FFF2-40B4-BE49-F238E27FC236}">
                 <a16:creationId xmlns:a16="http://schemas.microsoft.com/office/drawing/2014/main" id="{53220B4C-3EE9-79D0-5CC3-92E14004DE32}"/>
@@ -5473,7 +5522,7 @@
         </p:nvCxnSpPr>
         <p:spPr>
           <a:xfrm>
-            <a:off x="290502" y="716193"/>
+            <a:off x="290502" y="551390"/>
             <a:ext cx="541791" cy="0"/>
           </a:xfrm>
           <a:prstGeom prst="line">
@@ -5502,7 +5551,7 @@
       </p:cxnSp>
       <p:cxnSp>
         <p:nvCxnSpPr>
-          <p:cNvPr id="47" name="Straight Connector 46">
+          <p:cNvPr id="100" name="Straight Connector 99">
             <a:extLst>
               <a:ext uri="{FF2B5EF4-FFF2-40B4-BE49-F238E27FC236}">
                 <a16:creationId xmlns:a16="http://schemas.microsoft.com/office/drawing/2014/main" id="{CF1DEC7A-0060-1A4C-6A16-0B710C05E940}"/>
@@ -5516,7 +5565,7 @@
         </p:nvCxnSpPr>
         <p:spPr>
           <a:xfrm>
-            <a:off x="1344298" y="1230579"/>
+            <a:off x="1344298" y="1065776"/>
             <a:ext cx="540000" cy="0"/>
           </a:xfrm>
           <a:prstGeom prst="line">
@@ -5545,7 +5594,7 @@
       </p:cxnSp>
       <p:sp>
         <p:nvSpPr>
-          <p:cNvPr id="48" name="Freeform: Shape 47">
+          <p:cNvPr id="101" name="Freeform: Shape 100">
             <a:extLst>
               <a:ext uri="{FF2B5EF4-FFF2-40B4-BE49-F238E27FC236}">
                 <a16:creationId xmlns:a16="http://schemas.microsoft.com/office/drawing/2014/main" id="{5F39F989-143E-1301-D39A-44FA87B8671D}"/>
@@ -5557,7 +5606,7 @@
         </p:nvSpPr>
         <p:spPr>
           <a:xfrm rot="5400000">
-            <a:off x="2614889" y="509265"/>
+            <a:off x="2614889" y="344462"/>
             <a:ext cx="106550" cy="520390"/>
           </a:xfrm>
           <a:custGeom>
@@ -5684,7 +5733,7 @@
       </p:sp>
       <p:sp>
         <p:nvSpPr>
-          <p:cNvPr id="49" name="Freeform: Shape 48">
+          <p:cNvPr id="102" name="Freeform: Shape 101">
             <a:extLst>
               <a:ext uri="{FF2B5EF4-FFF2-40B4-BE49-F238E27FC236}">
                 <a16:creationId xmlns:a16="http://schemas.microsoft.com/office/drawing/2014/main" id="{45E4B854-239B-9566-3B89-532971E9DBFD}"/>
@@ -5696,7 +5745,7 @@
         </p:nvSpPr>
         <p:spPr>
           <a:xfrm rot="5400000">
-            <a:off x="3465741" y="700733"/>
+            <a:off x="3465741" y="535930"/>
             <a:ext cx="528159" cy="531532"/>
           </a:xfrm>
           <a:custGeom>
@@ -6104,7 +6153,7 @@
       </p:sp>
       <p:sp>
         <p:nvSpPr>
-          <p:cNvPr id="50" name="TextBox 49">
+          <p:cNvPr id="103" name="TextBox 102">
             <a:extLst>
               <a:ext uri="{FF2B5EF4-FFF2-40B4-BE49-F238E27FC236}">
                 <a16:creationId xmlns:a16="http://schemas.microsoft.com/office/drawing/2014/main" id="{551F3E36-7EC4-F8B9-3B05-22579CD90230}"/>
@@ -6116,7 +6165,7 @@
         </p:nvSpPr>
         <p:spPr>
           <a:xfrm rot="16200000">
-            <a:off x="805461" y="865263"/>
+            <a:off x="805461" y="700460"/>
             <a:ext cx="678565" cy="215444"/>
           </a:xfrm>
           <a:prstGeom prst="rect">
@@ -6149,7 +6198,7 @@
       </p:sp>
       <p:sp>
         <p:nvSpPr>
-          <p:cNvPr id="51" name="TextBox 50">
+          <p:cNvPr id="104" name="TextBox 103">
             <a:extLst>
               <a:ext uri="{FF2B5EF4-FFF2-40B4-BE49-F238E27FC236}">
                 <a16:creationId xmlns:a16="http://schemas.microsoft.com/office/drawing/2014/main" id="{B7776DAF-AB8C-150D-9732-CC67560B199A}"/>
@@ -6161,7 +6210,7 @@
         </p:nvSpPr>
         <p:spPr>
           <a:xfrm rot="16200000">
-            <a:off x="1844257" y="858704"/>
+            <a:off x="1844257" y="693901"/>
             <a:ext cx="678565" cy="215444"/>
           </a:xfrm>
           <a:prstGeom prst="rect">
@@ -6194,7 +6243,7 @@
       </p:sp>
       <p:sp>
         <p:nvSpPr>
-          <p:cNvPr id="52" name="TextBox 51">
+          <p:cNvPr id="105" name="TextBox 104">
             <a:extLst>
               <a:ext uri="{FF2B5EF4-FFF2-40B4-BE49-F238E27FC236}">
                 <a16:creationId xmlns:a16="http://schemas.microsoft.com/office/drawing/2014/main" id="{5A29D75E-81FE-2F24-F24E-E7FF79731679}"/>
@@ -6206,7 +6255,7 @@
         </p:nvSpPr>
         <p:spPr>
           <a:xfrm rot="16200000">
-            <a:off x="2894469" y="865264"/>
+            <a:off x="2894469" y="700461"/>
             <a:ext cx="678565" cy="215444"/>
           </a:xfrm>
           <a:prstGeom prst="rect">
@@ -6239,7 +6288,7 @@
       </p:sp>
       <p:sp>
         <p:nvSpPr>
-          <p:cNvPr id="53" name="Freeform: Shape 52">
+          <p:cNvPr id="106" name="Freeform: Shape 105">
             <a:extLst>
               <a:ext uri="{FF2B5EF4-FFF2-40B4-BE49-F238E27FC236}">
                 <a16:creationId xmlns:a16="http://schemas.microsoft.com/office/drawing/2014/main" id="{F6D48A6B-C064-E9C2-ABC9-C06729342EA6}"/>
@@ -6251,7 +6300,7 @@
         </p:nvSpPr>
         <p:spPr>
           <a:xfrm rot="5400000">
-            <a:off x="3581710" y="596668"/>
+            <a:off x="3581710" y="431865"/>
             <a:ext cx="292501" cy="531533"/>
           </a:xfrm>
           <a:custGeom>
@@ -6467,7 +6516,7 @@
       </p:sp>
       <p:sp>
         <p:nvSpPr>
-          <p:cNvPr id="54" name="TextBox 53">
+          <p:cNvPr id="107" name="TextBox 106">
             <a:extLst>
               <a:ext uri="{FF2B5EF4-FFF2-40B4-BE49-F238E27FC236}">
                 <a16:creationId xmlns:a16="http://schemas.microsoft.com/office/drawing/2014/main" id="{C28E69EA-3516-A310-AF50-988BB9504572}"/>
@@ -6479,7 +6528,7 @@
         </p:nvSpPr>
         <p:spPr>
           <a:xfrm>
-            <a:off x="3714693" y="666392"/>
+            <a:off x="3714693" y="501589"/>
             <a:ext cx="290464" cy="215444"/>
           </a:xfrm>
           <a:prstGeom prst="rect">
@@ -6512,7 +6561,7 @@
       </p:sp>
       <p:sp>
         <p:nvSpPr>
-          <p:cNvPr id="55" name="TextBox 54">
+          <p:cNvPr id="108" name="TextBox 107">
             <a:extLst>
               <a:ext uri="{FF2B5EF4-FFF2-40B4-BE49-F238E27FC236}">
                 <a16:creationId xmlns:a16="http://schemas.microsoft.com/office/drawing/2014/main" id="{9AFD7136-F527-E69D-7527-B98BDFD517F3}"/>
@@ -6524,7 +6573,7 @@
         </p:nvSpPr>
         <p:spPr>
           <a:xfrm>
-            <a:off x="3485123" y="948485"/>
+            <a:off x="3485123" y="783682"/>
             <a:ext cx="295274" cy="215444"/>
           </a:xfrm>
           <a:prstGeom prst="rect">
@@ -6557,7 +6606,7 @@
       </p:sp>
       <p:cxnSp>
         <p:nvCxnSpPr>
-          <p:cNvPr id="56" name="Straight Connector 55">
+          <p:cNvPr id="109" name="Straight Connector 108">
             <a:extLst>
               <a:ext uri="{FF2B5EF4-FFF2-40B4-BE49-F238E27FC236}">
                 <a16:creationId xmlns:a16="http://schemas.microsoft.com/office/drawing/2014/main" id="{A45691E5-0DBE-8798-0E11-D62DAD69F61A}"/>
@@ -6571,7 +6620,7 @@
         </p:nvCxnSpPr>
         <p:spPr>
           <a:xfrm flipH="1">
-            <a:off x="817229" y="702419"/>
+            <a:off x="817229" y="537616"/>
             <a:ext cx="0" cy="537043"/>
           </a:xfrm>
           <a:prstGeom prst="line">

</xml_diff>